<commit_message>
feat: add key-only Meeting Agent workflow
</commit_message>
<xml_diff>
--- a/Agents/Meeting-Agent/src/meeting_agent/templates/meeting-agent-template.pptx
+++ b/Agents/Meeting-Agent/src/meeting_agent/templates/meeting-agent-template.pptx
@@ -3089,7 +3089,7 @@
     <p:bg>
       <p:bgPr>
         <a:solidFill>
-          <a:srgbClr val="242424"/>
+          <a:srgbClr val="1A1A3E"/>
         </a:solidFill>
         <a:effectLst/>
       </p:bgPr>
@@ -3110,17 +3110,17 @@
         <p:spPr>
           <a:xfrm>
             <a:off x="0" y="0"/>
-            <a:ext cx="164592" cy="6858000"/>
+            <a:ext cx="146304" cy="6858000"/>
           </a:xfrm>
           <a:prstGeom prst="rect">
             <a:avLst/>
           </a:prstGeom>
           <a:solidFill>
-            <a:srgbClr val="B11F4B"/>
+            <a:srgbClr val="0078D4"/>
           </a:solidFill>
           <a:ln>
             <a:solidFill>
-              <a:srgbClr val="B11F4B"/>
+              <a:srgbClr val="0078D4"/>
             </a:solidFill>
           </a:ln>
         </p:spPr>
@@ -3154,18 +3154,18 @@
         </p:nvSpPr>
         <p:spPr>
           <a:xfrm>
-            <a:off x="8732520" y="0"/>
-            <a:ext cx="3456432" cy="6858000"/>
+            <a:off x="8686800" y="0"/>
+            <a:ext cx="3504895" cy="6858000"/>
           </a:xfrm>
           <a:prstGeom prst="rect">
             <a:avLst/>
           </a:prstGeom>
           <a:solidFill>
-            <a:srgbClr val="B11F4B"/>
+            <a:srgbClr val="1A1A3E"/>
           </a:solidFill>
           <a:ln>
             <a:solidFill>
-              <a:srgbClr val="B11F4B"/>
+              <a:srgbClr val="1A1A3E"/>
             </a:solidFill>
           </a:ln>
         </p:spPr>
@@ -3199,18 +3199,18 @@
         </p:nvSpPr>
         <p:spPr>
           <a:xfrm>
-            <a:off x="9372600" y="822960"/>
-            <a:ext cx="2240280" cy="1325880"/>
+            <a:off x="9098280" y="841248"/>
+            <a:ext cx="2487168" cy="1042415"/>
           </a:xfrm>
           <a:prstGeom prst="rect">
             <a:avLst/>
           </a:prstGeom>
           <a:solidFill>
-            <a:srgbClr val="007C83"/>
+            <a:srgbClr val="0078D4"/>
           </a:solidFill>
           <a:ln>
             <a:solidFill>
-              <a:srgbClr val="007C83"/>
+              <a:srgbClr val="0078D4"/>
             </a:solidFill>
           </a:ln>
         </p:spPr>
@@ -3244,18 +3244,18 @@
         </p:nvSpPr>
         <p:spPr>
           <a:xfrm>
-            <a:off x="9006840" y="2423160"/>
-            <a:ext cx="2606040" cy="960120"/>
+            <a:off x="9098280" y="2084831"/>
+            <a:ext cx="2487168" cy="1042415"/>
           </a:xfrm>
           <a:prstGeom prst="rect">
             <a:avLst/>
           </a:prstGeom>
           <a:solidFill>
-            <a:srgbClr val="E7A93B"/>
+            <a:srgbClr val="00B04F"/>
           </a:solidFill>
           <a:ln>
             <a:solidFill>
-              <a:srgbClr val="E7A93B"/>
+              <a:srgbClr val="00B04F"/>
             </a:solidFill>
           </a:ln>
         </p:spPr>
@@ -3289,18 +3289,18 @@
         </p:nvSpPr>
         <p:spPr>
           <a:xfrm>
-            <a:off x="9646920" y="3703320"/>
-            <a:ext cx="1965960" cy="2103120"/>
+            <a:off x="9098280" y="3328416"/>
+            <a:ext cx="2487168" cy="1042415"/>
           </a:xfrm>
           <a:prstGeom prst="rect">
             <a:avLst/>
           </a:prstGeom>
           <a:solidFill>
-            <a:srgbClr val="F7F4EF"/>
+            <a:srgbClr val="FFAA00"/>
           </a:solidFill>
           <a:ln>
             <a:solidFill>
-              <a:srgbClr val="F7F4EF"/>
+              <a:srgbClr val="FFAA00"/>
             </a:solidFill>
           </a:ln>
         </p:spPr>
@@ -3328,7 +3328,196 @@
       </p:sp>
       <p:sp>
         <p:nvSpPr>
-          <p:cNvPr id="7" name="MA_TITLE"/>
+          <p:cNvPr id="7" name="Rectangle 6"/>
+          <p:cNvSpPr/>
+          <p:nvPr/>
+        </p:nvSpPr>
+        <p:spPr>
+          <a:xfrm>
+            <a:off x="9098280" y="4572000"/>
+            <a:ext cx="2487168" cy="1042415"/>
+          </a:xfrm>
+          <a:prstGeom prst="rect">
+            <a:avLst/>
+          </a:prstGeom>
+          <a:solidFill>
+            <a:srgbClr val="7C3AED"/>
+          </a:solidFill>
+          <a:ln>
+            <a:solidFill>
+              <a:srgbClr val="7C3AED"/>
+            </a:solidFill>
+          </a:ln>
+        </p:spPr>
+        <p:style>
+          <a:lnRef idx="1">
+            <a:schemeClr val="accent1"/>
+          </a:lnRef>
+          <a:fillRef idx="3">
+            <a:schemeClr val="accent1"/>
+          </a:fillRef>
+          <a:effectRef idx="2">
+            <a:schemeClr val="accent1"/>
+          </a:effectRef>
+          <a:fontRef idx="minor">
+            <a:schemeClr val="lt1"/>
+          </a:fontRef>
+        </p:style>
+        <p:txBody>
+          <a:bodyPr rtlCol="0" anchor="ctr"/>
+          <a:lstStyle/>
+          <a:p>
+            <a:pPr algn="ctr"/>
+          </a:p>
+        </p:txBody>
+      </p:sp>
+      <p:sp>
+        <p:nvSpPr>
+          <p:cNvPr id="8" name="MA_COVER_STAGE_1"/>
+          <p:cNvSpPr txBox="1"/>
+          <p:nvPr/>
+        </p:nvSpPr>
+        <p:spPr>
+          <a:xfrm>
+            <a:off x="9345168" y="1143000"/>
+            <a:ext cx="2011680" cy="274320"/>
+          </a:xfrm>
+          <a:prstGeom prst="rect">
+            <a:avLst/>
+          </a:prstGeom>
+          <a:noFill/>
+        </p:spPr>
+        <p:txBody>
+          <a:bodyPr wrap="square" lIns="0" rIns="0" tIns="0" bIns="0" anchor="t">
+            <a:spAutoFit/>
+          </a:bodyPr>
+          <a:lstStyle/>
+          <a:p>
+            <a:pPr algn="ctr">
+              <a:defRPr sz="1200" b="1">
+                <a:solidFill>
+                  <a:srgbClr val="FFFFFF"/>
+                </a:solidFill>
+                <a:latin typeface="Segoe UI"/>
+              </a:defRPr>
+            </a:pPr>
+            <a:r>
+              <a:t>CAPTURE</a:t>
+            </a:r>
+          </a:p>
+        </p:txBody>
+      </p:sp>
+      <p:sp>
+        <p:nvSpPr>
+          <p:cNvPr id="9" name="MA_COVER_STAGE_2"/>
+          <p:cNvSpPr txBox="1"/>
+          <p:nvPr/>
+        </p:nvSpPr>
+        <p:spPr>
+          <a:xfrm>
+            <a:off x="9345168" y="2386584"/>
+            <a:ext cx="2011680" cy="274320"/>
+          </a:xfrm>
+          <a:prstGeom prst="rect">
+            <a:avLst/>
+          </a:prstGeom>
+          <a:noFill/>
+        </p:spPr>
+        <p:txBody>
+          <a:bodyPr wrap="square" lIns="0" rIns="0" tIns="0" bIns="0" anchor="t">
+            <a:spAutoFit/>
+          </a:bodyPr>
+          <a:lstStyle/>
+          <a:p>
+            <a:pPr algn="ctr">
+              <a:defRPr sz="1200" b="1">
+                <a:solidFill>
+                  <a:srgbClr val="FFFFFF"/>
+                </a:solidFill>
+                <a:latin typeface="Segoe UI"/>
+              </a:defRPr>
+            </a:pPr>
+            <a:r>
+              <a:t>UNDERSTAND</a:t>
+            </a:r>
+          </a:p>
+        </p:txBody>
+      </p:sp>
+      <p:sp>
+        <p:nvSpPr>
+          <p:cNvPr id="10" name="MA_COVER_STAGE_3"/>
+          <p:cNvSpPr txBox="1"/>
+          <p:nvPr/>
+        </p:nvSpPr>
+        <p:spPr>
+          <a:xfrm>
+            <a:off x="9345168" y="3630168"/>
+            <a:ext cx="2011680" cy="274320"/>
+          </a:xfrm>
+          <a:prstGeom prst="rect">
+            <a:avLst/>
+          </a:prstGeom>
+          <a:noFill/>
+        </p:spPr>
+        <p:txBody>
+          <a:bodyPr wrap="square" lIns="0" rIns="0" tIns="0" bIns="0" anchor="t">
+            <a:spAutoFit/>
+          </a:bodyPr>
+          <a:lstStyle/>
+          <a:p>
+            <a:pPr algn="ctr">
+              <a:defRPr sz="1200" b="1">
+                <a:solidFill>
+                  <a:srgbClr val="1A1A3E"/>
+                </a:solidFill>
+                <a:latin typeface="Segoe UI"/>
+              </a:defRPr>
+            </a:pPr>
+            <a:r>
+              <a:t>DECIDE</a:t>
+            </a:r>
+          </a:p>
+        </p:txBody>
+      </p:sp>
+      <p:sp>
+        <p:nvSpPr>
+          <p:cNvPr id="11" name="MA_COVER_STAGE_4"/>
+          <p:cNvSpPr txBox="1"/>
+          <p:nvPr/>
+        </p:nvSpPr>
+        <p:spPr>
+          <a:xfrm>
+            <a:off x="9345168" y="4873752"/>
+            <a:ext cx="2011680" cy="274320"/>
+          </a:xfrm>
+          <a:prstGeom prst="rect">
+            <a:avLst/>
+          </a:prstGeom>
+          <a:noFill/>
+        </p:spPr>
+        <p:txBody>
+          <a:bodyPr wrap="square" lIns="0" rIns="0" tIns="0" bIns="0" anchor="t">
+            <a:spAutoFit/>
+          </a:bodyPr>
+          <a:lstStyle/>
+          <a:p>
+            <a:pPr algn="ctr">
+              <a:defRPr sz="1200" b="1">
+                <a:solidFill>
+                  <a:srgbClr val="FFFFFF"/>
+                </a:solidFill>
+                <a:latin typeface="Segoe UI"/>
+              </a:defRPr>
+            </a:pPr>
+            <a:r>
+              <a:t>FOLLOW UP</a:t>
+            </a:r>
+          </a:p>
+        </p:txBody>
+      </p:sp>
+      <p:sp>
+        <p:nvSpPr>
+          <p:cNvPr id="12" name="MA_TITLE"/>
           <p:cNvSpPr txBox="1"/>
           <p:nvPr/>
         </p:nvSpPr>
@@ -3353,7 +3542,7 @@
                 <a:solidFill>
                   <a:srgbClr val="FFFFFF"/>
                 </a:solidFill>
-                <a:latin typeface="Aptos"/>
+                <a:latin typeface="Segoe UI"/>
               </a:defRPr>
             </a:pPr>
             <a:r>
@@ -3364,7 +3553,7 @@
       </p:sp>
       <p:sp>
         <p:nvSpPr>
-          <p:cNvPr id="8" name="MA_SUBTITLE"/>
+          <p:cNvPr id="13" name="MA_SUBTITLE"/>
           <p:cNvSpPr txBox="1"/>
           <p:nvPr/>
         </p:nvSpPr>
@@ -3389,18 +3578,18 @@
                 <a:solidFill>
                   <a:srgbClr val="FFFFFF"/>
                 </a:solidFill>
-                <a:latin typeface="Aptos"/>
+                <a:latin typeface="Segoe UI"/>
               </a:defRPr>
             </a:pPr>
             <a:r>
-              <a:t>Executive meeting package</a:t>
-            </a:r>
-          </a:p>
-        </p:txBody>
-      </p:sp>
-      <p:sp>
-        <p:nvSpPr>
-          <p:cNvPr id="9" name="MA_COVER_LABEL"/>
+              <a:t>Evidence-backed meeting intelligence package</a:t>
+            </a:r>
+          </a:p>
+        </p:txBody>
+      </p:sp>
+      <p:sp>
+        <p:nvSpPr>
+          <p:cNvPr id="14" name="MA_COVER_LABEL"/>
           <p:cNvSpPr txBox="1"/>
           <p:nvPr/>
         </p:nvSpPr>
@@ -3423,20 +3612,20 @@
             <a:pPr algn="l">
               <a:defRPr sz="1000" b="1">
                 <a:solidFill>
-                  <a:srgbClr val="E7A93B"/>
-                </a:solidFill>
-                <a:latin typeface="Aptos"/>
+                  <a:srgbClr val="FFAA00"/>
+                </a:solidFill>
+                <a:latin typeface="Segoe UI"/>
               </a:defRPr>
             </a:pPr>
             <a:r>
-              <a:t>MEETING AGENT  /  EVIDENCE TO ACTION</a:t>
-            </a:r>
-          </a:p>
-        </p:txBody>
-      </p:sp>
-      <p:sp>
-        <p:nvSpPr>
-          <p:cNvPr id="10" name="MA_COVER_FOOTER"/>
+              <a:t>MICROSOFT-STYLE MEETING READOUT  /  HUMAN REVIEWED</a:t>
+            </a:r>
+          </a:p>
+        </p:txBody>
+      </p:sp>
+      <p:sp>
+        <p:nvSpPr>
+          <p:cNvPr id="15" name="MA_COVER_FOOTER"/>
           <p:cNvSpPr txBox="1"/>
           <p:nvPr/>
         </p:nvSpPr>
@@ -3461,11 +3650,11 @@
                 <a:solidFill>
                   <a:srgbClr val="FFFFFF"/>
                 </a:solidFill>
-                <a:latin typeface="Aptos"/>
+                <a:latin typeface="Segoe UI"/>
               </a:defRPr>
             </a:pPr>
             <a:r>
-              <a:t>Generated from validated meeting evidence</a:t>
+              <a:t>Dynamic content generated from validated meeting evidence</a:t>
             </a:r>
           </a:p>
         </p:txBody>
@@ -3484,7 +3673,7 @@
     <p:bg>
       <p:bgPr>
         <a:solidFill>
-          <a:srgbClr val="F7F4EF"/>
+          <a:srgbClr val="FFFFFF"/>
         </a:solidFill>
         <a:effectLst/>
       </p:bgPr>
@@ -3498,13 +3687,58 @@
       <p:grpSpPr/>
       <p:sp>
         <p:nvSpPr>
-          <p:cNvPr id="2" name="MA_SECTION_2"/>
+          <p:cNvPr id="2" name="Rectangle 1"/>
+          <p:cNvSpPr/>
+          <p:nvPr/>
+        </p:nvSpPr>
+        <p:spPr>
+          <a:xfrm>
+            <a:off x="0" y="0"/>
+            <a:ext cx="12191695" cy="64008"/>
+          </a:xfrm>
+          <a:prstGeom prst="rect">
+            <a:avLst/>
+          </a:prstGeom>
+          <a:solidFill>
+            <a:srgbClr val="0078D4"/>
+          </a:solidFill>
+          <a:ln>
+            <a:solidFill>
+              <a:srgbClr val="0078D4"/>
+            </a:solidFill>
+          </a:ln>
+        </p:spPr>
+        <p:style>
+          <a:lnRef idx="1">
+            <a:schemeClr val="accent1"/>
+          </a:lnRef>
+          <a:fillRef idx="3">
+            <a:schemeClr val="accent1"/>
+          </a:fillRef>
+          <a:effectRef idx="2">
+            <a:schemeClr val="accent1"/>
+          </a:effectRef>
+          <a:fontRef idx="minor">
+            <a:schemeClr val="lt1"/>
+          </a:fontRef>
+        </p:style>
+        <p:txBody>
+          <a:bodyPr rtlCol="0" anchor="ctr"/>
+          <a:lstStyle/>
+          <a:p>
+            <a:pPr algn="ctr"/>
+          </a:p>
+        </p:txBody>
+      </p:sp>
+      <p:sp>
+        <p:nvSpPr>
+          <p:cNvPr id="3" name="MA_SECTION_2"/>
           <p:cNvSpPr txBox="1"/>
           <p:nvPr/>
         </p:nvSpPr>
         <p:spPr>
           <a:xfrm>
-            <a:off x="594360" y="347472"/>
+            <a:off x="530352" y="265176"/>
             <a:ext cx="2560320" cy="274320"/>
           </a:xfrm>
           <a:prstGeom prst="rect">
@@ -3519,11 +3753,11 @@
           <a:lstStyle/>
           <a:p>
             <a:pPr algn="l">
-              <a:defRPr sz="1000" b="1">
-                <a:solidFill>
-                  <a:srgbClr val="B11F4B"/>
-                </a:solidFill>
-                <a:latin typeface="Aptos"/>
+              <a:defRPr sz="900" b="1">
+                <a:solidFill>
+                  <a:srgbClr val="0078D4"/>
+                </a:solidFill>
+                <a:latin typeface="Segoe UI"/>
               </a:defRPr>
             </a:pPr>
             <a:r>
@@ -3534,13 +3768,13 @@
       </p:sp>
       <p:sp>
         <p:nvSpPr>
-          <p:cNvPr id="3" name="MA_SLIDE_TITLE_2"/>
+          <p:cNvPr id="4" name="MA_SLIDE_TITLE_2"/>
           <p:cNvSpPr txBox="1"/>
           <p:nvPr/>
         </p:nvSpPr>
         <p:spPr>
           <a:xfrm>
-            <a:off x="594360" y="713232"/>
+            <a:off x="530352" y="612648"/>
             <a:ext cx="10789920" cy="594360"/>
           </a:xfrm>
           <a:prstGeom prst="rect">
@@ -3555,11 +3789,11 @@
           <a:lstStyle/>
           <a:p>
             <a:pPr algn="l">
-              <a:defRPr sz="3000" b="1">
-                <a:solidFill>
-                  <a:srgbClr val="242424"/>
-                </a:solidFill>
-                <a:latin typeface="Aptos"/>
+              <a:defRPr sz="2800" b="1">
+                <a:solidFill>
+                  <a:srgbClr val="1A1A3E"/>
+                </a:solidFill>
+                <a:latin typeface="Segoe UI"/>
               </a:defRPr>
             </a:pPr>
             <a:r>
@@ -3570,14 +3804,14 @@
       </p:sp>
       <p:sp>
         <p:nvSpPr>
-          <p:cNvPr id="4" name="MA_PAGE_2"/>
+          <p:cNvPr id="5" name="MA_FOOTER_2"/>
           <p:cNvSpPr txBox="1"/>
           <p:nvPr/>
         </p:nvSpPr>
         <p:spPr>
           <a:xfrm>
-            <a:off x="11018520" y="6446520"/>
-            <a:ext cx="548640" cy="182880"/>
+            <a:off x="530352" y="6446520"/>
+            <a:ext cx="4297680" cy="182880"/>
           </a:xfrm>
           <a:prstGeom prst="rect">
             <a:avLst/>
@@ -3590,12 +3824,48 @@
           </a:bodyPr>
           <a:lstStyle/>
           <a:p>
+            <a:pPr algn="l">
+              <a:defRPr sz="800" b="1">
+                <a:solidFill>
+                  <a:srgbClr val="606070"/>
+                </a:solidFill>
+                <a:latin typeface="Segoe UI"/>
+              </a:defRPr>
+            </a:pPr>
+            <a:r>
+              <a:t>STARGATE  /  MEETING INTELLIGENCE</a:t>
+            </a:r>
+          </a:p>
+        </p:txBody>
+      </p:sp>
+      <p:sp>
+        <p:nvSpPr>
+          <p:cNvPr id="6" name="MA_PAGE_2"/>
+          <p:cNvSpPr txBox="1"/>
+          <p:nvPr/>
+        </p:nvSpPr>
+        <p:spPr>
+          <a:xfrm>
+            <a:off x="11018520" y="6446520"/>
+            <a:ext cx="548640" cy="182880"/>
+          </a:xfrm>
+          <a:prstGeom prst="rect">
+            <a:avLst/>
+          </a:prstGeom>
+          <a:noFill/>
+        </p:spPr>
+        <p:txBody>
+          <a:bodyPr wrap="square" lIns="0" rIns="0" tIns="0" bIns="0" anchor="t">
+            <a:spAutoFit/>
+          </a:bodyPr>
+          <a:lstStyle/>
+          <a:p>
             <a:pPr algn="r">
               <a:defRPr sz="900" b="0">
                 <a:solidFill>
-                  <a:srgbClr val="68645F"/>
-                </a:solidFill>
-                <a:latin typeface="Aptos"/>
+                  <a:srgbClr val="606070"/>
+                </a:solidFill>
+                <a:latin typeface="Segoe UI"/>
               </a:defRPr>
             </a:pPr>
             <a:r>
@@ -3606,7 +3876,7 @@
       </p:sp>
       <p:sp>
         <p:nvSpPr>
-          <p:cNvPr id="5" name="Rounded Rectangle 4"/>
+          <p:cNvPr id="7" name="Rounded Rectangle 6"/>
           <p:cNvSpPr/>
           <p:nvPr/>
         </p:nvSpPr>
@@ -3623,7 +3893,7 @@
           </a:solidFill>
           <a:ln>
             <a:solidFill>
-              <a:srgbClr val="D9D7D2"/>
+              <a:srgbClr val="D9DCE8"/>
             </a:solidFill>
           </a:ln>
         </p:spPr>
@@ -3651,7 +3921,7 @@
       </p:sp>
       <p:sp>
         <p:nvSpPr>
-          <p:cNvPr id="6" name="MA_SUMMARY"/>
+          <p:cNvPr id="8" name="MA_SUMMARY"/>
           <p:cNvSpPr txBox="1"/>
           <p:nvPr/>
         </p:nvSpPr>
@@ -3674,9 +3944,9 @@
             <a:pPr algn="l">
               <a:defRPr sz="2000" b="0">
                 <a:solidFill>
-                  <a:srgbClr val="242424"/>
-                </a:solidFill>
-                <a:latin typeface="Aptos"/>
+                  <a:srgbClr val="1A1A3E"/>
+                </a:solidFill>
+                <a:latin typeface="Segoe UI"/>
               </a:defRPr>
             </a:pPr>
             <a:r>
@@ -3687,7 +3957,7 @@
       </p:sp>
       <p:sp>
         <p:nvSpPr>
-          <p:cNvPr id="7" name="Rounded Rectangle 6"/>
+          <p:cNvPr id="9" name="Rounded Rectangle 8"/>
           <p:cNvSpPr/>
           <p:nvPr/>
         </p:nvSpPr>
@@ -3704,7 +3974,7 @@
           </a:solidFill>
           <a:ln>
             <a:solidFill>
-              <a:srgbClr val="D9D7D2"/>
+              <a:srgbClr val="D9DCE8"/>
             </a:solidFill>
           </a:ln>
         </p:spPr>
@@ -3732,7 +4002,7 @@
       </p:sp>
       <p:sp>
         <p:nvSpPr>
-          <p:cNvPr id="8" name="Rectangle 7"/>
+          <p:cNvPr id="10" name="Rectangle 9"/>
           <p:cNvSpPr/>
           <p:nvPr/>
         </p:nvSpPr>
@@ -3745,11 +4015,11 @@
             <a:avLst/>
           </a:prstGeom>
           <a:solidFill>
-            <a:srgbClr val="007C83"/>
+            <a:srgbClr val="00B04F"/>
           </a:solidFill>
           <a:ln>
             <a:solidFill>
-              <a:srgbClr val="007C83"/>
+              <a:srgbClr val="00B04F"/>
             </a:solidFill>
           </a:ln>
         </p:spPr>
@@ -3777,7 +4047,7 @@
       </p:sp>
       <p:sp>
         <p:nvSpPr>
-          <p:cNvPr id="9" name="MA_TOPIC_COUNT"/>
+          <p:cNvPr id="11" name="MA_TOPIC_COUNT"/>
           <p:cNvSpPr txBox="1"/>
           <p:nvPr/>
         </p:nvSpPr>
@@ -3800,9 +4070,9 @@
             <a:pPr algn="l">
               <a:defRPr sz="2700" b="1">
                 <a:solidFill>
-                  <a:srgbClr val="007C83"/>
-                </a:solidFill>
-                <a:latin typeface="Aptos"/>
+                  <a:srgbClr val="00B04F"/>
+                </a:solidFill>
+                <a:latin typeface="Segoe UI"/>
               </a:defRPr>
             </a:pPr>
             <a:r>
@@ -3813,7 +4083,7 @@
       </p:sp>
       <p:sp>
         <p:nvSpPr>
-          <p:cNvPr id="10" name="MA_TOPIC_COUNT_LABEL"/>
+          <p:cNvPr id="12" name="MA_TOPIC_COUNT_LABEL"/>
           <p:cNvSpPr txBox="1"/>
           <p:nvPr/>
         </p:nvSpPr>
@@ -3836,9 +4106,9 @@
             <a:pPr algn="l">
               <a:defRPr sz="1000" b="1">
                 <a:solidFill>
-                  <a:srgbClr val="68645F"/>
-                </a:solidFill>
-                <a:latin typeface="Aptos"/>
+                  <a:srgbClr val="606070"/>
+                </a:solidFill>
+                <a:latin typeface="Segoe UI"/>
               </a:defRPr>
             </a:pPr>
             <a:r>
@@ -3849,7 +4119,7 @@
       </p:sp>
       <p:sp>
         <p:nvSpPr>
-          <p:cNvPr id="11" name="Rounded Rectangle 10"/>
+          <p:cNvPr id="13" name="Rounded Rectangle 12"/>
           <p:cNvSpPr/>
           <p:nvPr/>
         </p:nvSpPr>
@@ -3866,7 +4136,7 @@
           </a:solidFill>
           <a:ln>
             <a:solidFill>
-              <a:srgbClr val="D9D7D2"/>
+              <a:srgbClr val="D9DCE8"/>
             </a:solidFill>
           </a:ln>
         </p:spPr>
@@ -3894,7 +4164,7 @@
       </p:sp>
       <p:sp>
         <p:nvSpPr>
-          <p:cNvPr id="12" name="Rectangle 11"/>
+          <p:cNvPr id="14" name="Rectangle 13"/>
           <p:cNvSpPr/>
           <p:nvPr/>
         </p:nvSpPr>
@@ -3907,11 +4177,11 @@
             <a:avLst/>
           </a:prstGeom>
           <a:solidFill>
-            <a:srgbClr val="B11F4B"/>
+            <a:srgbClr val="0078D4"/>
           </a:solidFill>
           <a:ln>
             <a:solidFill>
-              <a:srgbClr val="B11F4B"/>
+              <a:srgbClr val="0078D4"/>
             </a:solidFill>
           </a:ln>
         </p:spPr>
@@ -3939,7 +4209,7 @@
       </p:sp>
       <p:sp>
         <p:nvSpPr>
-          <p:cNvPr id="13" name="MA_DECISION_COUNT"/>
+          <p:cNvPr id="15" name="MA_DECISION_COUNT"/>
           <p:cNvSpPr txBox="1"/>
           <p:nvPr/>
         </p:nvSpPr>
@@ -3962,9 +4232,9 @@
             <a:pPr algn="l">
               <a:defRPr sz="2700" b="1">
                 <a:solidFill>
-                  <a:srgbClr val="B11F4B"/>
-                </a:solidFill>
-                <a:latin typeface="Aptos"/>
+                  <a:srgbClr val="0078D4"/>
+                </a:solidFill>
+                <a:latin typeface="Segoe UI"/>
               </a:defRPr>
             </a:pPr>
             <a:r>
@@ -3975,7 +4245,7 @@
       </p:sp>
       <p:sp>
         <p:nvSpPr>
-          <p:cNvPr id="14" name="MA_DECISION_COUNT_LABEL"/>
+          <p:cNvPr id="16" name="MA_DECISION_COUNT_LABEL"/>
           <p:cNvSpPr txBox="1"/>
           <p:nvPr/>
         </p:nvSpPr>
@@ -3998,9 +4268,9 @@
             <a:pPr algn="l">
               <a:defRPr sz="1000" b="1">
                 <a:solidFill>
-                  <a:srgbClr val="68645F"/>
-                </a:solidFill>
-                <a:latin typeface="Aptos"/>
+                  <a:srgbClr val="606070"/>
+                </a:solidFill>
+                <a:latin typeface="Segoe UI"/>
               </a:defRPr>
             </a:pPr>
             <a:r>
@@ -4011,7 +4281,7 @@
       </p:sp>
       <p:sp>
         <p:nvSpPr>
-          <p:cNvPr id="15" name="Rounded Rectangle 14"/>
+          <p:cNvPr id="17" name="Rounded Rectangle 16"/>
           <p:cNvSpPr/>
           <p:nvPr/>
         </p:nvSpPr>
@@ -4028,7 +4298,7 @@
           </a:solidFill>
           <a:ln>
             <a:solidFill>
-              <a:srgbClr val="D9D7D2"/>
+              <a:srgbClr val="D9DCE8"/>
             </a:solidFill>
           </a:ln>
         </p:spPr>
@@ -4056,7 +4326,7 @@
       </p:sp>
       <p:sp>
         <p:nvSpPr>
-          <p:cNvPr id="16" name="Rectangle 15"/>
+          <p:cNvPr id="18" name="Rectangle 17"/>
           <p:cNvSpPr/>
           <p:nvPr/>
         </p:nvSpPr>
@@ -4069,11 +4339,11 @@
             <a:avLst/>
           </a:prstGeom>
           <a:solidFill>
-            <a:srgbClr val="E7A93B"/>
+            <a:srgbClr val="FFAA00"/>
           </a:solidFill>
           <a:ln>
             <a:solidFill>
-              <a:srgbClr val="E7A93B"/>
+              <a:srgbClr val="FFAA00"/>
             </a:solidFill>
           </a:ln>
         </p:spPr>
@@ -4101,7 +4371,7 @@
       </p:sp>
       <p:sp>
         <p:nvSpPr>
-          <p:cNvPr id="17" name="MA_ACTION_COUNT"/>
+          <p:cNvPr id="19" name="MA_ACTION_COUNT"/>
           <p:cNvSpPr txBox="1"/>
           <p:nvPr/>
         </p:nvSpPr>
@@ -4124,9 +4394,9 @@
             <a:pPr algn="l">
               <a:defRPr sz="2700" b="1">
                 <a:solidFill>
-                  <a:srgbClr val="E7A93B"/>
-                </a:solidFill>
-                <a:latin typeface="Aptos"/>
+                  <a:srgbClr val="FFAA00"/>
+                </a:solidFill>
+                <a:latin typeface="Segoe UI"/>
               </a:defRPr>
             </a:pPr>
             <a:r>
@@ -4137,7 +4407,7 @@
       </p:sp>
       <p:sp>
         <p:nvSpPr>
-          <p:cNvPr id="18" name="MA_ACTION_COUNT_LABEL"/>
+          <p:cNvPr id="20" name="MA_ACTION_COUNT_LABEL"/>
           <p:cNvSpPr txBox="1"/>
           <p:nvPr/>
         </p:nvSpPr>
@@ -4160,9 +4430,9 @@
             <a:pPr algn="l">
               <a:defRPr sz="1000" b="1">
                 <a:solidFill>
-                  <a:srgbClr val="68645F"/>
-                </a:solidFill>
-                <a:latin typeface="Aptos"/>
+                  <a:srgbClr val="606070"/>
+                </a:solidFill>
+                <a:latin typeface="Segoe UI"/>
               </a:defRPr>
             </a:pPr>
             <a:r>
@@ -4185,7 +4455,7 @@
     <p:bg>
       <p:bgPr>
         <a:solidFill>
-          <a:srgbClr val="F7F4EF"/>
+          <a:srgbClr val="FFFFFF"/>
         </a:solidFill>
         <a:effectLst/>
       </p:bgPr>
@@ -4199,132 +4469,24 @@
       <p:grpSpPr/>
       <p:sp>
         <p:nvSpPr>
-          <p:cNvPr id="2" name="MA_SECTION_3"/>
-          <p:cNvSpPr txBox="1"/>
-          <p:nvPr/>
-        </p:nvSpPr>
-        <p:spPr>
-          <a:xfrm>
-            <a:off x="594360" y="347472"/>
-            <a:ext cx="2560320" cy="274320"/>
-          </a:xfrm>
-          <a:prstGeom prst="rect">
-            <a:avLst/>
-          </a:prstGeom>
-          <a:noFill/>
-        </p:spPr>
-        <p:txBody>
-          <a:bodyPr wrap="square" lIns="0" rIns="0" tIns="0" bIns="0" anchor="t">
-            <a:spAutoFit/>
-          </a:bodyPr>
-          <a:lstStyle/>
-          <a:p>
-            <a:pPr algn="l">
-              <a:defRPr sz="1000" b="1">
-                <a:solidFill>
-                  <a:srgbClr val="B11F4B"/>
-                </a:solidFill>
-                <a:latin typeface="Aptos"/>
-              </a:defRPr>
-            </a:pPr>
-            <a:r>
-              <a:t>02 / THEMES</a:t>
-            </a:r>
-          </a:p>
-        </p:txBody>
-      </p:sp>
-      <p:sp>
-        <p:nvSpPr>
-          <p:cNvPr id="3" name="MA_SLIDE_TITLE_3"/>
-          <p:cNvSpPr txBox="1"/>
-          <p:nvPr/>
-        </p:nvSpPr>
-        <p:spPr>
-          <a:xfrm>
-            <a:off x="594360" y="713232"/>
-            <a:ext cx="10789920" cy="594360"/>
-          </a:xfrm>
-          <a:prstGeom prst="rect">
-            <a:avLst/>
-          </a:prstGeom>
-          <a:noFill/>
-        </p:spPr>
-        <p:txBody>
-          <a:bodyPr wrap="square" lIns="0" rIns="0" tIns="0" bIns="0" anchor="t">
-            <a:spAutoFit/>
-          </a:bodyPr>
-          <a:lstStyle/>
-          <a:p>
-            <a:pPr algn="l">
-              <a:defRPr sz="3000" b="1">
-                <a:solidFill>
-                  <a:srgbClr val="242424"/>
-                </a:solidFill>
-                <a:latin typeface="Aptos"/>
-              </a:defRPr>
-            </a:pPr>
-            <a:r>
-              <a:t>What shaped the discussion</a:t>
-            </a:r>
-          </a:p>
-        </p:txBody>
-      </p:sp>
-      <p:sp>
-        <p:nvSpPr>
-          <p:cNvPr id="4" name="MA_PAGE_3"/>
-          <p:cNvSpPr txBox="1"/>
-          <p:nvPr/>
-        </p:nvSpPr>
-        <p:spPr>
-          <a:xfrm>
-            <a:off x="11018520" y="6446520"/>
-            <a:ext cx="548640" cy="182880"/>
-          </a:xfrm>
-          <a:prstGeom prst="rect">
-            <a:avLst/>
-          </a:prstGeom>
-          <a:noFill/>
-        </p:spPr>
-        <p:txBody>
-          <a:bodyPr wrap="square" lIns="0" rIns="0" tIns="0" bIns="0" anchor="t">
-            <a:spAutoFit/>
-          </a:bodyPr>
-          <a:lstStyle/>
-          <a:p>
-            <a:pPr algn="r">
-              <a:defRPr sz="900" b="0">
-                <a:solidFill>
-                  <a:srgbClr val="68645F"/>
-                </a:solidFill>
-                <a:latin typeface="Aptos"/>
-              </a:defRPr>
-            </a:pPr>
-            <a:r>
-              <a:t>03</a:t>
-            </a:r>
-          </a:p>
-        </p:txBody>
-      </p:sp>
-      <p:sp>
-        <p:nvSpPr>
-          <p:cNvPr id="5" name="Rounded Rectangle 4"/>
+          <p:cNvPr id="2" name="Rectangle 1"/>
           <p:cNvSpPr/>
           <p:nvPr/>
         </p:nvSpPr>
         <p:spPr>
           <a:xfrm>
-            <a:off x="594360" y="1627632"/>
-            <a:ext cx="3456432" cy="4343400"/>
-          </a:xfrm>
-          <a:prstGeom prst="roundRect">
+            <a:off x="0" y="0"/>
+            <a:ext cx="12191695" cy="64008"/>
+          </a:xfrm>
+          <a:prstGeom prst="rect">
             <a:avLst/>
           </a:prstGeom>
           <a:solidFill>
-            <a:srgbClr val="FFFFFF"/>
+            <a:srgbClr val="0078D4"/>
           </a:solidFill>
           <a:ln>
             <a:solidFill>
-              <a:srgbClr val="D9D7D2"/>
+              <a:srgbClr val="0078D4"/>
             </a:solidFill>
           </a:ln>
         </p:spPr>
@@ -4352,24 +4514,168 @@
       </p:sp>
       <p:sp>
         <p:nvSpPr>
-          <p:cNvPr id="6" name="Rectangle 5"/>
+          <p:cNvPr id="3" name="MA_SECTION_3"/>
+          <p:cNvSpPr txBox="1"/>
+          <p:nvPr/>
+        </p:nvSpPr>
+        <p:spPr>
+          <a:xfrm>
+            <a:off x="530352" y="265176"/>
+            <a:ext cx="2560320" cy="274320"/>
+          </a:xfrm>
+          <a:prstGeom prst="rect">
+            <a:avLst/>
+          </a:prstGeom>
+          <a:noFill/>
+        </p:spPr>
+        <p:txBody>
+          <a:bodyPr wrap="square" lIns="0" rIns="0" tIns="0" bIns="0" anchor="t">
+            <a:spAutoFit/>
+          </a:bodyPr>
+          <a:lstStyle/>
+          <a:p>
+            <a:pPr algn="l">
+              <a:defRPr sz="900" b="1">
+                <a:solidFill>
+                  <a:srgbClr val="0078D4"/>
+                </a:solidFill>
+                <a:latin typeface="Segoe UI"/>
+              </a:defRPr>
+            </a:pPr>
+            <a:r>
+              <a:t>02 / THEMES</a:t>
+            </a:r>
+          </a:p>
+        </p:txBody>
+      </p:sp>
+      <p:sp>
+        <p:nvSpPr>
+          <p:cNvPr id="4" name="MA_SLIDE_TITLE_3"/>
+          <p:cNvSpPr txBox="1"/>
+          <p:nvPr/>
+        </p:nvSpPr>
+        <p:spPr>
+          <a:xfrm>
+            <a:off x="530352" y="612648"/>
+            <a:ext cx="10789920" cy="594360"/>
+          </a:xfrm>
+          <a:prstGeom prst="rect">
+            <a:avLst/>
+          </a:prstGeom>
+          <a:noFill/>
+        </p:spPr>
+        <p:txBody>
+          <a:bodyPr wrap="square" lIns="0" rIns="0" tIns="0" bIns="0" anchor="t">
+            <a:spAutoFit/>
+          </a:bodyPr>
+          <a:lstStyle/>
+          <a:p>
+            <a:pPr algn="l">
+              <a:defRPr sz="2800" b="1">
+                <a:solidFill>
+                  <a:srgbClr val="1A1A3E"/>
+                </a:solidFill>
+                <a:latin typeface="Segoe UI"/>
+              </a:defRPr>
+            </a:pPr>
+            <a:r>
+              <a:t>What shaped the discussion</a:t>
+            </a:r>
+          </a:p>
+        </p:txBody>
+      </p:sp>
+      <p:sp>
+        <p:nvSpPr>
+          <p:cNvPr id="5" name="MA_FOOTER_3"/>
+          <p:cNvSpPr txBox="1"/>
+          <p:nvPr/>
+        </p:nvSpPr>
+        <p:spPr>
+          <a:xfrm>
+            <a:off x="530352" y="6446520"/>
+            <a:ext cx="4297680" cy="182880"/>
+          </a:xfrm>
+          <a:prstGeom prst="rect">
+            <a:avLst/>
+          </a:prstGeom>
+          <a:noFill/>
+        </p:spPr>
+        <p:txBody>
+          <a:bodyPr wrap="square" lIns="0" rIns="0" tIns="0" bIns="0" anchor="t">
+            <a:spAutoFit/>
+          </a:bodyPr>
+          <a:lstStyle/>
+          <a:p>
+            <a:pPr algn="l">
+              <a:defRPr sz="800" b="1">
+                <a:solidFill>
+                  <a:srgbClr val="606070"/>
+                </a:solidFill>
+                <a:latin typeface="Segoe UI"/>
+              </a:defRPr>
+            </a:pPr>
+            <a:r>
+              <a:t>STARGATE  /  MEETING INTELLIGENCE</a:t>
+            </a:r>
+          </a:p>
+        </p:txBody>
+      </p:sp>
+      <p:sp>
+        <p:nvSpPr>
+          <p:cNvPr id="6" name="MA_PAGE_3"/>
+          <p:cNvSpPr txBox="1"/>
+          <p:nvPr/>
+        </p:nvSpPr>
+        <p:spPr>
+          <a:xfrm>
+            <a:off x="11018520" y="6446520"/>
+            <a:ext cx="548640" cy="182880"/>
+          </a:xfrm>
+          <a:prstGeom prst="rect">
+            <a:avLst/>
+          </a:prstGeom>
+          <a:noFill/>
+        </p:spPr>
+        <p:txBody>
+          <a:bodyPr wrap="square" lIns="0" rIns="0" tIns="0" bIns="0" anchor="t">
+            <a:spAutoFit/>
+          </a:bodyPr>
+          <a:lstStyle/>
+          <a:p>
+            <a:pPr algn="r">
+              <a:defRPr sz="900" b="0">
+                <a:solidFill>
+                  <a:srgbClr val="606070"/>
+                </a:solidFill>
+                <a:latin typeface="Segoe UI"/>
+              </a:defRPr>
+            </a:pPr>
+            <a:r>
+              <a:t>03</a:t>
+            </a:r>
+          </a:p>
+        </p:txBody>
+      </p:sp>
+      <p:sp>
+        <p:nvSpPr>
+          <p:cNvPr id="7" name="MA_TOPIC_CARD_1"/>
           <p:cNvSpPr/>
           <p:nvPr/>
         </p:nvSpPr>
         <p:spPr>
           <a:xfrm>
-            <a:off x="594360" y="1627632"/>
-            <a:ext cx="3456432" cy="128016"/>
-          </a:xfrm>
-          <a:prstGeom prst="rect">
+            <a:off x="530352" y="1389888"/>
+            <a:ext cx="3547872" cy="2029968"/>
+          </a:xfrm>
+          <a:prstGeom prst="roundRect">
             <a:avLst/>
           </a:prstGeom>
           <a:solidFill>
-            <a:srgbClr val="B11F4B"/>
+            <a:srgbClr val="F3F4F8"/>
           </a:solidFill>
           <a:ln>
             <a:solidFill>
-              <a:srgbClr val="B11F4B"/>
+              <a:srgbClr val="D9DCE8"/>
             </a:solidFill>
           </a:ln>
         </p:spPr>
@@ -4397,96 +4703,24 @@
       </p:sp>
       <p:sp>
         <p:nvSpPr>
-          <p:cNvPr id="7" name="MA_TOPIC_INDEX_1"/>
-          <p:cNvSpPr txBox="1"/>
-          <p:nvPr/>
-        </p:nvSpPr>
-        <p:spPr>
-          <a:xfrm>
-            <a:off x="886968" y="1965960"/>
-            <a:ext cx="594360" cy="365760"/>
-          </a:xfrm>
-          <a:prstGeom prst="rect">
-            <a:avLst/>
-          </a:prstGeom>
-          <a:noFill/>
-        </p:spPr>
-        <p:txBody>
-          <a:bodyPr wrap="square" lIns="0" rIns="0" tIns="0" bIns="0" anchor="t">
-            <a:spAutoFit/>
-          </a:bodyPr>
-          <a:lstStyle/>
-          <a:p>
-            <a:pPr algn="l">
-              <a:defRPr sz="1600" b="1">
-                <a:solidFill>
-                  <a:srgbClr val="B11F4B"/>
-                </a:solidFill>
-                <a:latin typeface="Aptos"/>
-              </a:defRPr>
-            </a:pPr>
-            <a:r>
-              <a:t>01</a:t>
-            </a:r>
-          </a:p>
-        </p:txBody>
-      </p:sp>
-      <p:sp>
-        <p:nvSpPr>
-          <p:cNvPr id="8" name="MA_TOPICS_1"/>
-          <p:cNvSpPr txBox="1"/>
-          <p:nvPr/>
-        </p:nvSpPr>
-        <p:spPr>
-          <a:xfrm>
-            <a:off x="886968" y="2514600"/>
-            <a:ext cx="2852928" cy="2971800"/>
-          </a:xfrm>
-          <a:prstGeom prst="rect">
-            <a:avLst/>
-          </a:prstGeom>
-          <a:noFill/>
-        </p:spPr>
-        <p:txBody>
-          <a:bodyPr wrap="square" lIns="0" rIns="0" tIns="0" bIns="0" anchor="t">
-            <a:spAutoFit/>
-          </a:bodyPr>
-          <a:lstStyle/>
-          <a:p>
-            <a:pPr algn="l">
-              <a:defRPr sz="1700" b="0">
-                <a:solidFill>
-                  <a:srgbClr val="242424"/>
-                </a:solidFill>
-                <a:latin typeface="Aptos"/>
-              </a:defRPr>
-            </a:pPr>
-            <a:r>
-              <a:t>Topic content</a:t>
-            </a:r>
-          </a:p>
-        </p:txBody>
-      </p:sp>
-      <p:sp>
-        <p:nvSpPr>
-          <p:cNvPr id="9" name="Rounded Rectangle 8"/>
+          <p:cNvPr id="8" name="MA_TOPIC_STRIPE_1"/>
           <p:cNvSpPr/>
           <p:nvPr/>
         </p:nvSpPr>
         <p:spPr>
           <a:xfrm>
-            <a:off x="4416552" y="1627632"/>
-            <a:ext cx="3456432" cy="4343400"/>
-          </a:xfrm>
-          <a:prstGeom prst="roundRect">
+            <a:off x="530352" y="1389888"/>
+            <a:ext cx="91440" cy="2029968"/>
+          </a:xfrm>
+          <a:prstGeom prst="rect">
             <a:avLst/>
           </a:prstGeom>
           <a:solidFill>
-            <a:srgbClr val="FFFFFF"/>
+            <a:srgbClr val="0078D4"/>
           </a:solidFill>
           <a:ln>
             <a:solidFill>
-              <a:srgbClr val="D9D7D2"/>
+              <a:srgbClr val="0078D4"/>
             </a:solidFill>
           </a:ln>
         </p:spPr>
@@ -4514,24 +4748,96 @@
       </p:sp>
       <p:sp>
         <p:nvSpPr>
-          <p:cNvPr id="10" name="Rectangle 9"/>
+          <p:cNvPr id="9" name="MA_TOPIC_INDEX_1"/>
+          <p:cNvSpPr txBox="1"/>
+          <p:nvPr/>
+        </p:nvSpPr>
+        <p:spPr>
+          <a:xfrm>
+            <a:off x="822959" y="1645920"/>
+            <a:ext cx="594360" cy="365760"/>
+          </a:xfrm>
+          <a:prstGeom prst="rect">
+            <a:avLst/>
+          </a:prstGeom>
+          <a:noFill/>
+        </p:spPr>
+        <p:txBody>
+          <a:bodyPr wrap="square" lIns="0" rIns="0" tIns="0" bIns="0" anchor="t">
+            <a:spAutoFit/>
+          </a:bodyPr>
+          <a:lstStyle/>
+          <a:p>
+            <a:pPr algn="l">
+              <a:defRPr sz="1400" b="1">
+                <a:solidFill>
+                  <a:srgbClr val="0078D4"/>
+                </a:solidFill>
+                <a:latin typeface="Segoe UI"/>
+              </a:defRPr>
+            </a:pPr>
+            <a:r>
+              <a:t>01</a:t>
+            </a:r>
+          </a:p>
+        </p:txBody>
+      </p:sp>
+      <p:sp>
+        <p:nvSpPr>
+          <p:cNvPr id="10" name="MA_TOPICS_1"/>
+          <p:cNvSpPr txBox="1"/>
+          <p:nvPr/>
+        </p:nvSpPr>
+        <p:spPr>
+          <a:xfrm>
+            <a:off x="822959" y="2176272"/>
+            <a:ext cx="2852928" cy="914400"/>
+          </a:xfrm>
+          <a:prstGeom prst="rect">
+            <a:avLst/>
+          </a:prstGeom>
+          <a:noFill/>
+        </p:spPr>
+        <p:txBody>
+          <a:bodyPr wrap="square" lIns="0" rIns="0" tIns="0" bIns="0" anchor="t">
+            <a:spAutoFit/>
+          </a:bodyPr>
+          <a:lstStyle/>
+          <a:p>
+            <a:pPr algn="l">
+              <a:defRPr sz="1600" b="1">
+                <a:solidFill>
+                  <a:srgbClr val="1A1A3E"/>
+                </a:solidFill>
+                <a:latin typeface="Segoe UI"/>
+              </a:defRPr>
+            </a:pPr>
+            <a:r>
+              <a:t>Topic content</a:t>
+            </a:r>
+          </a:p>
+        </p:txBody>
+      </p:sp>
+      <p:sp>
+        <p:nvSpPr>
+          <p:cNvPr id="11" name="MA_TOPIC_CARD_2"/>
           <p:cNvSpPr/>
           <p:nvPr/>
         </p:nvSpPr>
         <p:spPr>
           <a:xfrm>
-            <a:off x="4416552" y="1627632"/>
-            <a:ext cx="3456432" cy="128016"/>
-          </a:xfrm>
-          <a:prstGeom prst="rect">
+            <a:off x="4398264" y="1389888"/>
+            <a:ext cx="3547872" cy="2029968"/>
+          </a:xfrm>
+          <a:prstGeom prst="roundRect">
             <a:avLst/>
           </a:prstGeom>
           <a:solidFill>
-            <a:srgbClr val="007C83"/>
+            <a:srgbClr val="F3F4F8"/>
           </a:solidFill>
           <a:ln>
             <a:solidFill>
-              <a:srgbClr val="007C83"/>
+              <a:srgbClr val="D9DCE8"/>
             </a:solidFill>
           </a:ln>
         </p:spPr>
@@ -4559,96 +4865,24 @@
       </p:sp>
       <p:sp>
         <p:nvSpPr>
-          <p:cNvPr id="11" name="MA_TOPIC_INDEX_2"/>
-          <p:cNvSpPr txBox="1"/>
-          <p:nvPr/>
-        </p:nvSpPr>
-        <p:spPr>
-          <a:xfrm>
-            <a:off x="4709160" y="1965960"/>
-            <a:ext cx="594360" cy="365760"/>
-          </a:xfrm>
-          <a:prstGeom prst="rect">
-            <a:avLst/>
-          </a:prstGeom>
-          <a:noFill/>
-        </p:spPr>
-        <p:txBody>
-          <a:bodyPr wrap="square" lIns="0" rIns="0" tIns="0" bIns="0" anchor="t">
-            <a:spAutoFit/>
-          </a:bodyPr>
-          <a:lstStyle/>
-          <a:p>
-            <a:pPr algn="l">
-              <a:defRPr sz="1600" b="1">
-                <a:solidFill>
-                  <a:srgbClr val="007C83"/>
-                </a:solidFill>
-                <a:latin typeface="Aptos"/>
-              </a:defRPr>
-            </a:pPr>
-            <a:r>
-              <a:t>02</a:t>
-            </a:r>
-          </a:p>
-        </p:txBody>
-      </p:sp>
-      <p:sp>
-        <p:nvSpPr>
-          <p:cNvPr id="12" name="MA_TOPICS_2"/>
-          <p:cNvSpPr txBox="1"/>
-          <p:nvPr/>
-        </p:nvSpPr>
-        <p:spPr>
-          <a:xfrm>
-            <a:off x="4709160" y="2514600"/>
-            <a:ext cx="2852928" cy="2971800"/>
-          </a:xfrm>
-          <a:prstGeom prst="rect">
-            <a:avLst/>
-          </a:prstGeom>
-          <a:noFill/>
-        </p:spPr>
-        <p:txBody>
-          <a:bodyPr wrap="square" lIns="0" rIns="0" tIns="0" bIns="0" anchor="t">
-            <a:spAutoFit/>
-          </a:bodyPr>
-          <a:lstStyle/>
-          <a:p>
-            <a:pPr algn="l">
-              <a:defRPr sz="1700" b="0">
-                <a:solidFill>
-                  <a:srgbClr val="242424"/>
-                </a:solidFill>
-                <a:latin typeface="Aptos"/>
-              </a:defRPr>
-            </a:pPr>
-            <a:r>
-              <a:t>Topic content</a:t>
-            </a:r>
-          </a:p>
-        </p:txBody>
-      </p:sp>
-      <p:sp>
-        <p:nvSpPr>
-          <p:cNvPr id="13" name="Rounded Rectangle 12"/>
+          <p:cNvPr id="12" name="MA_TOPIC_STRIPE_2"/>
           <p:cNvSpPr/>
           <p:nvPr/>
         </p:nvSpPr>
         <p:spPr>
           <a:xfrm>
-            <a:off x="8238744" y="1627632"/>
-            <a:ext cx="3456432" cy="4343400"/>
-          </a:xfrm>
-          <a:prstGeom prst="roundRect">
+            <a:off x="4398264" y="1389888"/>
+            <a:ext cx="91440" cy="2029968"/>
+          </a:xfrm>
+          <a:prstGeom prst="rect">
             <a:avLst/>
           </a:prstGeom>
           <a:solidFill>
-            <a:srgbClr val="FFFFFF"/>
+            <a:srgbClr val="00B04F"/>
           </a:solidFill>
           <a:ln>
             <a:solidFill>
-              <a:srgbClr val="D9D7D2"/>
+              <a:srgbClr val="00B04F"/>
             </a:solidFill>
           </a:ln>
         </p:spPr>
@@ -4676,24 +4910,96 @@
       </p:sp>
       <p:sp>
         <p:nvSpPr>
-          <p:cNvPr id="14" name="Rectangle 13"/>
+          <p:cNvPr id="13" name="MA_TOPIC_INDEX_2"/>
+          <p:cNvSpPr txBox="1"/>
+          <p:nvPr/>
+        </p:nvSpPr>
+        <p:spPr>
+          <a:xfrm>
+            <a:off x="4690872" y="1645920"/>
+            <a:ext cx="594360" cy="365760"/>
+          </a:xfrm>
+          <a:prstGeom prst="rect">
+            <a:avLst/>
+          </a:prstGeom>
+          <a:noFill/>
+        </p:spPr>
+        <p:txBody>
+          <a:bodyPr wrap="square" lIns="0" rIns="0" tIns="0" bIns="0" anchor="t">
+            <a:spAutoFit/>
+          </a:bodyPr>
+          <a:lstStyle/>
+          <a:p>
+            <a:pPr algn="l">
+              <a:defRPr sz="1400" b="1">
+                <a:solidFill>
+                  <a:srgbClr val="00B04F"/>
+                </a:solidFill>
+                <a:latin typeface="Segoe UI"/>
+              </a:defRPr>
+            </a:pPr>
+            <a:r>
+              <a:t>02</a:t>
+            </a:r>
+          </a:p>
+        </p:txBody>
+      </p:sp>
+      <p:sp>
+        <p:nvSpPr>
+          <p:cNvPr id="14" name="MA_TOPICS_2"/>
+          <p:cNvSpPr txBox="1"/>
+          <p:nvPr/>
+        </p:nvSpPr>
+        <p:spPr>
+          <a:xfrm>
+            <a:off x="4690872" y="2176272"/>
+            <a:ext cx="2852928" cy="914400"/>
+          </a:xfrm>
+          <a:prstGeom prst="rect">
+            <a:avLst/>
+          </a:prstGeom>
+          <a:noFill/>
+        </p:spPr>
+        <p:txBody>
+          <a:bodyPr wrap="square" lIns="0" rIns="0" tIns="0" bIns="0" anchor="t">
+            <a:spAutoFit/>
+          </a:bodyPr>
+          <a:lstStyle/>
+          <a:p>
+            <a:pPr algn="l">
+              <a:defRPr sz="1600" b="1">
+                <a:solidFill>
+                  <a:srgbClr val="1A1A3E"/>
+                </a:solidFill>
+                <a:latin typeface="Segoe UI"/>
+              </a:defRPr>
+            </a:pPr>
+            <a:r>
+              <a:t>Topic content</a:t>
+            </a:r>
+          </a:p>
+        </p:txBody>
+      </p:sp>
+      <p:sp>
+        <p:nvSpPr>
+          <p:cNvPr id="15" name="MA_TOPIC_CARD_3"/>
           <p:cNvSpPr/>
           <p:nvPr/>
         </p:nvSpPr>
         <p:spPr>
           <a:xfrm>
-            <a:off x="8238744" y="1627632"/>
-            <a:ext cx="3456432" cy="128016"/>
-          </a:xfrm>
-          <a:prstGeom prst="rect">
+            <a:off x="8266176" y="1389888"/>
+            <a:ext cx="3547872" cy="2029968"/>
+          </a:xfrm>
+          <a:prstGeom prst="roundRect">
             <a:avLst/>
           </a:prstGeom>
           <a:solidFill>
-            <a:srgbClr val="E7A93B"/>
+            <a:srgbClr val="F3F4F8"/>
           </a:solidFill>
           <a:ln>
             <a:solidFill>
-              <a:srgbClr val="E7A93B"/>
+              <a:srgbClr val="D9DCE8"/>
             </a:solidFill>
           </a:ln>
         </p:spPr>
@@ -4721,13 +5027,58 @@
       </p:sp>
       <p:sp>
         <p:nvSpPr>
-          <p:cNvPr id="15" name="MA_TOPIC_INDEX_3"/>
+          <p:cNvPr id="16" name="MA_TOPIC_STRIPE_3"/>
+          <p:cNvSpPr/>
+          <p:nvPr/>
+        </p:nvSpPr>
+        <p:spPr>
+          <a:xfrm>
+            <a:off x="8266176" y="1389888"/>
+            <a:ext cx="91440" cy="2029968"/>
+          </a:xfrm>
+          <a:prstGeom prst="rect">
+            <a:avLst/>
+          </a:prstGeom>
+          <a:solidFill>
+            <a:srgbClr val="FFAA00"/>
+          </a:solidFill>
+          <a:ln>
+            <a:solidFill>
+              <a:srgbClr val="FFAA00"/>
+            </a:solidFill>
+          </a:ln>
+        </p:spPr>
+        <p:style>
+          <a:lnRef idx="1">
+            <a:schemeClr val="accent1"/>
+          </a:lnRef>
+          <a:fillRef idx="3">
+            <a:schemeClr val="accent1"/>
+          </a:fillRef>
+          <a:effectRef idx="2">
+            <a:schemeClr val="accent1"/>
+          </a:effectRef>
+          <a:fontRef idx="minor">
+            <a:schemeClr val="lt1"/>
+          </a:fontRef>
+        </p:style>
+        <p:txBody>
+          <a:bodyPr rtlCol="0" anchor="ctr"/>
+          <a:lstStyle/>
+          <a:p>
+            <a:pPr algn="ctr"/>
+          </a:p>
+        </p:txBody>
+      </p:sp>
+      <p:sp>
+        <p:nvSpPr>
+          <p:cNvPr id="17" name="MA_TOPIC_INDEX_3"/>
           <p:cNvSpPr txBox="1"/>
           <p:nvPr/>
         </p:nvSpPr>
         <p:spPr>
           <a:xfrm>
-            <a:off x="8531352" y="1965960"/>
+            <a:off x="8558784" y="1645920"/>
             <a:ext cx="594360" cy="365760"/>
           </a:xfrm>
           <a:prstGeom prst="rect">
@@ -4742,11 +5093,11 @@
           <a:lstStyle/>
           <a:p>
             <a:pPr algn="l">
-              <a:defRPr sz="1600" b="1">
-                <a:solidFill>
-                  <a:srgbClr val="E7A93B"/>
-                </a:solidFill>
-                <a:latin typeface="Aptos"/>
+              <a:defRPr sz="1400" b="1">
+                <a:solidFill>
+                  <a:srgbClr val="FFAA00"/>
+                </a:solidFill>
+                <a:latin typeface="Segoe UI"/>
               </a:defRPr>
             </a:pPr>
             <a:r>
@@ -4757,14 +5108,14 @@
       </p:sp>
       <p:sp>
         <p:nvSpPr>
-          <p:cNvPr id="16" name="MA_TOPICS_3"/>
+          <p:cNvPr id="18" name="MA_TOPICS_3"/>
           <p:cNvSpPr txBox="1"/>
           <p:nvPr/>
         </p:nvSpPr>
         <p:spPr>
           <a:xfrm>
-            <a:off x="8531352" y="2514600"/>
-            <a:ext cx="2852928" cy="2971800"/>
+            <a:off x="8558784" y="2176272"/>
+            <a:ext cx="2852928" cy="914400"/>
           </a:xfrm>
           <a:prstGeom prst="rect">
             <a:avLst/>
@@ -4778,11 +5129,497 @@
           <a:lstStyle/>
           <a:p>
             <a:pPr algn="l">
-              <a:defRPr sz="1700" b="0">
-                <a:solidFill>
-                  <a:srgbClr val="242424"/>
-                </a:solidFill>
-                <a:latin typeface="Aptos"/>
+              <a:defRPr sz="1600" b="1">
+                <a:solidFill>
+                  <a:srgbClr val="1A1A3E"/>
+                </a:solidFill>
+                <a:latin typeface="Segoe UI"/>
+              </a:defRPr>
+            </a:pPr>
+            <a:r>
+              <a:t>Topic content</a:t>
+            </a:r>
+          </a:p>
+        </p:txBody>
+      </p:sp>
+      <p:sp>
+        <p:nvSpPr>
+          <p:cNvPr id="19" name="MA_TOPIC_CARD_4"/>
+          <p:cNvSpPr/>
+          <p:nvPr/>
+        </p:nvSpPr>
+        <p:spPr>
+          <a:xfrm>
+            <a:off x="530352" y="3721608"/>
+            <a:ext cx="3547872" cy="2029968"/>
+          </a:xfrm>
+          <a:prstGeom prst="roundRect">
+            <a:avLst/>
+          </a:prstGeom>
+          <a:solidFill>
+            <a:srgbClr val="F3F4F8"/>
+          </a:solidFill>
+          <a:ln>
+            <a:solidFill>
+              <a:srgbClr val="D9DCE8"/>
+            </a:solidFill>
+          </a:ln>
+        </p:spPr>
+        <p:style>
+          <a:lnRef idx="1">
+            <a:schemeClr val="accent1"/>
+          </a:lnRef>
+          <a:fillRef idx="3">
+            <a:schemeClr val="accent1"/>
+          </a:fillRef>
+          <a:effectRef idx="2">
+            <a:schemeClr val="accent1"/>
+          </a:effectRef>
+          <a:fontRef idx="minor">
+            <a:schemeClr val="lt1"/>
+          </a:fontRef>
+        </p:style>
+        <p:txBody>
+          <a:bodyPr rtlCol="0" anchor="ctr"/>
+          <a:lstStyle/>
+          <a:p>
+            <a:pPr algn="ctr"/>
+          </a:p>
+        </p:txBody>
+      </p:sp>
+      <p:sp>
+        <p:nvSpPr>
+          <p:cNvPr id="20" name="MA_TOPIC_STRIPE_4"/>
+          <p:cNvSpPr/>
+          <p:nvPr/>
+        </p:nvSpPr>
+        <p:spPr>
+          <a:xfrm>
+            <a:off x="530352" y="3721608"/>
+            <a:ext cx="91440" cy="2029968"/>
+          </a:xfrm>
+          <a:prstGeom prst="rect">
+            <a:avLst/>
+          </a:prstGeom>
+          <a:solidFill>
+            <a:srgbClr val="7C3AED"/>
+          </a:solidFill>
+          <a:ln>
+            <a:solidFill>
+              <a:srgbClr val="7C3AED"/>
+            </a:solidFill>
+          </a:ln>
+        </p:spPr>
+        <p:style>
+          <a:lnRef idx="1">
+            <a:schemeClr val="accent1"/>
+          </a:lnRef>
+          <a:fillRef idx="3">
+            <a:schemeClr val="accent1"/>
+          </a:fillRef>
+          <a:effectRef idx="2">
+            <a:schemeClr val="accent1"/>
+          </a:effectRef>
+          <a:fontRef idx="minor">
+            <a:schemeClr val="lt1"/>
+          </a:fontRef>
+        </p:style>
+        <p:txBody>
+          <a:bodyPr rtlCol="0" anchor="ctr"/>
+          <a:lstStyle/>
+          <a:p>
+            <a:pPr algn="ctr"/>
+          </a:p>
+        </p:txBody>
+      </p:sp>
+      <p:sp>
+        <p:nvSpPr>
+          <p:cNvPr id="21" name="MA_TOPIC_INDEX_4"/>
+          <p:cNvSpPr txBox="1"/>
+          <p:nvPr/>
+        </p:nvSpPr>
+        <p:spPr>
+          <a:xfrm>
+            <a:off x="822959" y="3977640"/>
+            <a:ext cx="594360" cy="365760"/>
+          </a:xfrm>
+          <a:prstGeom prst="rect">
+            <a:avLst/>
+          </a:prstGeom>
+          <a:noFill/>
+        </p:spPr>
+        <p:txBody>
+          <a:bodyPr wrap="square" lIns="0" rIns="0" tIns="0" bIns="0" anchor="t">
+            <a:spAutoFit/>
+          </a:bodyPr>
+          <a:lstStyle/>
+          <a:p>
+            <a:pPr algn="l">
+              <a:defRPr sz="1400" b="1">
+                <a:solidFill>
+                  <a:srgbClr val="7C3AED"/>
+                </a:solidFill>
+                <a:latin typeface="Segoe UI"/>
+              </a:defRPr>
+            </a:pPr>
+            <a:r>
+              <a:t>04</a:t>
+            </a:r>
+          </a:p>
+        </p:txBody>
+      </p:sp>
+      <p:sp>
+        <p:nvSpPr>
+          <p:cNvPr id="22" name="MA_TOPICS_4"/>
+          <p:cNvSpPr txBox="1"/>
+          <p:nvPr/>
+        </p:nvSpPr>
+        <p:spPr>
+          <a:xfrm>
+            <a:off x="822959" y="4507992"/>
+            <a:ext cx="2852928" cy="914400"/>
+          </a:xfrm>
+          <a:prstGeom prst="rect">
+            <a:avLst/>
+          </a:prstGeom>
+          <a:noFill/>
+        </p:spPr>
+        <p:txBody>
+          <a:bodyPr wrap="square" lIns="0" rIns="0" tIns="0" bIns="0" anchor="t">
+            <a:spAutoFit/>
+          </a:bodyPr>
+          <a:lstStyle/>
+          <a:p>
+            <a:pPr algn="l">
+              <a:defRPr sz="1600" b="1">
+                <a:solidFill>
+                  <a:srgbClr val="1A1A3E"/>
+                </a:solidFill>
+                <a:latin typeface="Segoe UI"/>
+              </a:defRPr>
+            </a:pPr>
+            <a:r>
+              <a:t>Topic content</a:t>
+            </a:r>
+          </a:p>
+        </p:txBody>
+      </p:sp>
+      <p:sp>
+        <p:nvSpPr>
+          <p:cNvPr id="23" name="MA_TOPIC_CARD_5"/>
+          <p:cNvSpPr/>
+          <p:nvPr/>
+        </p:nvSpPr>
+        <p:spPr>
+          <a:xfrm>
+            <a:off x="4398264" y="3721608"/>
+            <a:ext cx="3547872" cy="2029968"/>
+          </a:xfrm>
+          <a:prstGeom prst="roundRect">
+            <a:avLst/>
+          </a:prstGeom>
+          <a:solidFill>
+            <a:srgbClr val="F3F4F8"/>
+          </a:solidFill>
+          <a:ln>
+            <a:solidFill>
+              <a:srgbClr val="D9DCE8"/>
+            </a:solidFill>
+          </a:ln>
+        </p:spPr>
+        <p:style>
+          <a:lnRef idx="1">
+            <a:schemeClr val="accent1"/>
+          </a:lnRef>
+          <a:fillRef idx="3">
+            <a:schemeClr val="accent1"/>
+          </a:fillRef>
+          <a:effectRef idx="2">
+            <a:schemeClr val="accent1"/>
+          </a:effectRef>
+          <a:fontRef idx="minor">
+            <a:schemeClr val="lt1"/>
+          </a:fontRef>
+        </p:style>
+        <p:txBody>
+          <a:bodyPr rtlCol="0" anchor="ctr"/>
+          <a:lstStyle/>
+          <a:p>
+            <a:pPr algn="ctr"/>
+          </a:p>
+        </p:txBody>
+      </p:sp>
+      <p:sp>
+        <p:nvSpPr>
+          <p:cNvPr id="24" name="MA_TOPIC_STRIPE_5"/>
+          <p:cNvSpPr/>
+          <p:nvPr/>
+        </p:nvSpPr>
+        <p:spPr>
+          <a:xfrm>
+            <a:off x="4398264" y="3721608"/>
+            <a:ext cx="91440" cy="2029968"/>
+          </a:xfrm>
+          <a:prstGeom prst="rect">
+            <a:avLst/>
+          </a:prstGeom>
+          <a:solidFill>
+            <a:srgbClr val="E74C3C"/>
+          </a:solidFill>
+          <a:ln>
+            <a:solidFill>
+              <a:srgbClr val="E74C3C"/>
+            </a:solidFill>
+          </a:ln>
+        </p:spPr>
+        <p:style>
+          <a:lnRef idx="1">
+            <a:schemeClr val="accent1"/>
+          </a:lnRef>
+          <a:fillRef idx="3">
+            <a:schemeClr val="accent1"/>
+          </a:fillRef>
+          <a:effectRef idx="2">
+            <a:schemeClr val="accent1"/>
+          </a:effectRef>
+          <a:fontRef idx="minor">
+            <a:schemeClr val="lt1"/>
+          </a:fontRef>
+        </p:style>
+        <p:txBody>
+          <a:bodyPr rtlCol="0" anchor="ctr"/>
+          <a:lstStyle/>
+          <a:p>
+            <a:pPr algn="ctr"/>
+          </a:p>
+        </p:txBody>
+      </p:sp>
+      <p:sp>
+        <p:nvSpPr>
+          <p:cNvPr id="25" name="MA_TOPIC_INDEX_5"/>
+          <p:cNvSpPr txBox="1"/>
+          <p:nvPr/>
+        </p:nvSpPr>
+        <p:spPr>
+          <a:xfrm>
+            <a:off x="4690872" y="3977640"/>
+            <a:ext cx="594360" cy="365760"/>
+          </a:xfrm>
+          <a:prstGeom prst="rect">
+            <a:avLst/>
+          </a:prstGeom>
+          <a:noFill/>
+        </p:spPr>
+        <p:txBody>
+          <a:bodyPr wrap="square" lIns="0" rIns="0" tIns="0" bIns="0" anchor="t">
+            <a:spAutoFit/>
+          </a:bodyPr>
+          <a:lstStyle/>
+          <a:p>
+            <a:pPr algn="l">
+              <a:defRPr sz="1400" b="1">
+                <a:solidFill>
+                  <a:srgbClr val="E74C3C"/>
+                </a:solidFill>
+                <a:latin typeface="Segoe UI"/>
+              </a:defRPr>
+            </a:pPr>
+            <a:r>
+              <a:t>05</a:t>
+            </a:r>
+          </a:p>
+        </p:txBody>
+      </p:sp>
+      <p:sp>
+        <p:nvSpPr>
+          <p:cNvPr id="26" name="MA_TOPICS_5"/>
+          <p:cNvSpPr txBox="1"/>
+          <p:nvPr/>
+        </p:nvSpPr>
+        <p:spPr>
+          <a:xfrm>
+            <a:off x="4690872" y="4507992"/>
+            <a:ext cx="2852928" cy="914400"/>
+          </a:xfrm>
+          <a:prstGeom prst="rect">
+            <a:avLst/>
+          </a:prstGeom>
+          <a:noFill/>
+        </p:spPr>
+        <p:txBody>
+          <a:bodyPr wrap="square" lIns="0" rIns="0" tIns="0" bIns="0" anchor="t">
+            <a:spAutoFit/>
+          </a:bodyPr>
+          <a:lstStyle/>
+          <a:p>
+            <a:pPr algn="l">
+              <a:defRPr sz="1600" b="1">
+                <a:solidFill>
+                  <a:srgbClr val="1A1A3E"/>
+                </a:solidFill>
+                <a:latin typeface="Segoe UI"/>
+              </a:defRPr>
+            </a:pPr>
+            <a:r>
+              <a:t>Topic content</a:t>
+            </a:r>
+          </a:p>
+        </p:txBody>
+      </p:sp>
+      <p:sp>
+        <p:nvSpPr>
+          <p:cNvPr id="27" name="MA_TOPIC_CARD_6"/>
+          <p:cNvSpPr/>
+          <p:nvPr/>
+        </p:nvSpPr>
+        <p:spPr>
+          <a:xfrm>
+            <a:off x="8266176" y="3721608"/>
+            <a:ext cx="3547872" cy="2029968"/>
+          </a:xfrm>
+          <a:prstGeom prst="roundRect">
+            <a:avLst/>
+          </a:prstGeom>
+          <a:solidFill>
+            <a:srgbClr val="F3F4F8"/>
+          </a:solidFill>
+          <a:ln>
+            <a:solidFill>
+              <a:srgbClr val="D9DCE8"/>
+            </a:solidFill>
+          </a:ln>
+        </p:spPr>
+        <p:style>
+          <a:lnRef idx="1">
+            <a:schemeClr val="accent1"/>
+          </a:lnRef>
+          <a:fillRef idx="3">
+            <a:schemeClr val="accent1"/>
+          </a:fillRef>
+          <a:effectRef idx="2">
+            <a:schemeClr val="accent1"/>
+          </a:effectRef>
+          <a:fontRef idx="minor">
+            <a:schemeClr val="lt1"/>
+          </a:fontRef>
+        </p:style>
+        <p:txBody>
+          <a:bodyPr rtlCol="0" anchor="ctr"/>
+          <a:lstStyle/>
+          <a:p>
+            <a:pPr algn="ctr"/>
+          </a:p>
+        </p:txBody>
+      </p:sp>
+      <p:sp>
+        <p:nvSpPr>
+          <p:cNvPr id="28" name="MA_TOPIC_STRIPE_6"/>
+          <p:cNvSpPr/>
+          <p:nvPr/>
+        </p:nvSpPr>
+        <p:spPr>
+          <a:xfrm>
+            <a:off x="8266176" y="3721608"/>
+            <a:ext cx="91440" cy="2029968"/>
+          </a:xfrm>
+          <a:prstGeom prst="rect">
+            <a:avLst/>
+          </a:prstGeom>
+          <a:solidFill>
+            <a:srgbClr val="0078D4"/>
+          </a:solidFill>
+          <a:ln>
+            <a:solidFill>
+              <a:srgbClr val="0078D4"/>
+            </a:solidFill>
+          </a:ln>
+        </p:spPr>
+        <p:style>
+          <a:lnRef idx="1">
+            <a:schemeClr val="accent1"/>
+          </a:lnRef>
+          <a:fillRef idx="3">
+            <a:schemeClr val="accent1"/>
+          </a:fillRef>
+          <a:effectRef idx="2">
+            <a:schemeClr val="accent1"/>
+          </a:effectRef>
+          <a:fontRef idx="minor">
+            <a:schemeClr val="lt1"/>
+          </a:fontRef>
+        </p:style>
+        <p:txBody>
+          <a:bodyPr rtlCol="0" anchor="ctr"/>
+          <a:lstStyle/>
+          <a:p>
+            <a:pPr algn="ctr"/>
+          </a:p>
+        </p:txBody>
+      </p:sp>
+      <p:sp>
+        <p:nvSpPr>
+          <p:cNvPr id="29" name="MA_TOPIC_INDEX_6"/>
+          <p:cNvSpPr txBox="1"/>
+          <p:nvPr/>
+        </p:nvSpPr>
+        <p:spPr>
+          <a:xfrm>
+            <a:off x="8558784" y="3977640"/>
+            <a:ext cx="594360" cy="365760"/>
+          </a:xfrm>
+          <a:prstGeom prst="rect">
+            <a:avLst/>
+          </a:prstGeom>
+          <a:noFill/>
+        </p:spPr>
+        <p:txBody>
+          <a:bodyPr wrap="square" lIns="0" rIns="0" tIns="0" bIns="0" anchor="t">
+            <a:spAutoFit/>
+          </a:bodyPr>
+          <a:lstStyle/>
+          <a:p>
+            <a:pPr algn="l">
+              <a:defRPr sz="1400" b="1">
+                <a:solidFill>
+                  <a:srgbClr val="0078D4"/>
+                </a:solidFill>
+                <a:latin typeface="Segoe UI"/>
+              </a:defRPr>
+            </a:pPr>
+            <a:r>
+              <a:t>06</a:t>
+            </a:r>
+          </a:p>
+        </p:txBody>
+      </p:sp>
+      <p:sp>
+        <p:nvSpPr>
+          <p:cNvPr id="30" name="MA_TOPICS_6"/>
+          <p:cNvSpPr txBox="1"/>
+          <p:nvPr/>
+        </p:nvSpPr>
+        <p:spPr>
+          <a:xfrm>
+            <a:off x="8558784" y="4507992"/>
+            <a:ext cx="2852928" cy="914400"/>
+          </a:xfrm>
+          <a:prstGeom prst="rect">
+            <a:avLst/>
+          </a:prstGeom>
+          <a:noFill/>
+        </p:spPr>
+        <p:txBody>
+          <a:bodyPr wrap="square" lIns="0" rIns="0" tIns="0" bIns="0" anchor="t">
+            <a:spAutoFit/>
+          </a:bodyPr>
+          <a:lstStyle/>
+          <a:p>
+            <a:pPr algn="l">
+              <a:defRPr sz="1600" b="1">
+                <a:solidFill>
+                  <a:srgbClr val="1A1A3E"/>
+                </a:solidFill>
+                <a:latin typeface="Segoe UI"/>
               </a:defRPr>
             </a:pPr>
             <a:r>
@@ -4805,7 +5642,7 @@
     <p:bg>
       <p:bgPr>
         <a:solidFill>
-          <a:srgbClr val="F7F4EF"/>
+          <a:srgbClr val="FFFFFF"/>
         </a:solidFill>
         <a:effectLst/>
       </p:bgPr>
@@ -4819,13 +5656,58 @@
       <p:grpSpPr/>
       <p:sp>
         <p:nvSpPr>
-          <p:cNvPr id="2" name="MA_SECTION_4"/>
+          <p:cNvPr id="2" name="Rectangle 1"/>
+          <p:cNvSpPr/>
+          <p:nvPr/>
+        </p:nvSpPr>
+        <p:spPr>
+          <a:xfrm>
+            <a:off x="0" y="0"/>
+            <a:ext cx="12191695" cy="64008"/>
+          </a:xfrm>
+          <a:prstGeom prst="rect">
+            <a:avLst/>
+          </a:prstGeom>
+          <a:solidFill>
+            <a:srgbClr val="0078D4"/>
+          </a:solidFill>
+          <a:ln>
+            <a:solidFill>
+              <a:srgbClr val="0078D4"/>
+            </a:solidFill>
+          </a:ln>
+        </p:spPr>
+        <p:style>
+          <a:lnRef idx="1">
+            <a:schemeClr val="accent1"/>
+          </a:lnRef>
+          <a:fillRef idx="3">
+            <a:schemeClr val="accent1"/>
+          </a:fillRef>
+          <a:effectRef idx="2">
+            <a:schemeClr val="accent1"/>
+          </a:effectRef>
+          <a:fontRef idx="minor">
+            <a:schemeClr val="lt1"/>
+          </a:fontRef>
+        </p:style>
+        <p:txBody>
+          <a:bodyPr rtlCol="0" anchor="ctr"/>
+          <a:lstStyle/>
+          <a:p>
+            <a:pPr algn="ctr"/>
+          </a:p>
+        </p:txBody>
+      </p:sp>
+      <p:sp>
+        <p:nvSpPr>
+          <p:cNvPr id="3" name="MA_SECTION_4"/>
           <p:cNvSpPr txBox="1"/>
           <p:nvPr/>
         </p:nvSpPr>
         <p:spPr>
           <a:xfrm>
-            <a:off x="594360" y="347472"/>
+            <a:off x="530352" y="265176"/>
             <a:ext cx="2560320" cy="274320"/>
           </a:xfrm>
           <a:prstGeom prst="rect">
@@ -4840,11 +5722,11 @@
           <a:lstStyle/>
           <a:p>
             <a:pPr algn="l">
-              <a:defRPr sz="1000" b="1">
-                <a:solidFill>
-                  <a:srgbClr val="B11F4B"/>
-                </a:solidFill>
-                <a:latin typeface="Aptos"/>
+              <a:defRPr sz="900" b="1">
+                <a:solidFill>
+                  <a:srgbClr val="0078D4"/>
+                </a:solidFill>
+                <a:latin typeface="Segoe UI"/>
               </a:defRPr>
             </a:pPr>
             <a:r>
@@ -4855,13 +5737,13 @@
       </p:sp>
       <p:sp>
         <p:nvSpPr>
-          <p:cNvPr id="3" name="MA_SLIDE_TITLE_4"/>
+          <p:cNvPr id="4" name="MA_SLIDE_TITLE_4"/>
           <p:cNvSpPr txBox="1"/>
           <p:nvPr/>
         </p:nvSpPr>
         <p:spPr>
           <a:xfrm>
-            <a:off x="594360" y="713232"/>
+            <a:off x="530352" y="612648"/>
             <a:ext cx="10789920" cy="594360"/>
           </a:xfrm>
           <a:prstGeom prst="rect">
@@ -4876,11 +5758,11 @@
           <a:lstStyle/>
           <a:p>
             <a:pPr algn="l">
-              <a:defRPr sz="3000" b="1">
-                <a:solidFill>
-                  <a:srgbClr val="242424"/>
-                </a:solidFill>
-                <a:latin typeface="Aptos"/>
+              <a:defRPr sz="2800" b="1">
+                <a:solidFill>
+                  <a:srgbClr val="1A1A3E"/>
+                </a:solidFill>
+                <a:latin typeface="Segoe UI"/>
               </a:defRPr>
             </a:pPr>
             <a:r>
@@ -4891,14 +5773,14 @@
       </p:sp>
       <p:sp>
         <p:nvSpPr>
-          <p:cNvPr id="4" name="MA_PAGE_4"/>
+          <p:cNvPr id="5" name="MA_FOOTER_4"/>
           <p:cNvSpPr txBox="1"/>
           <p:nvPr/>
         </p:nvSpPr>
         <p:spPr>
           <a:xfrm>
-            <a:off x="11018520" y="6446520"/>
-            <a:ext cx="548640" cy="182880"/>
+            <a:off x="530352" y="6446520"/>
+            <a:ext cx="4297680" cy="182880"/>
           </a:xfrm>
           <a:prstGeom prst="rect">
             <a:avLst/>
@@ -4911,12 +5793,48 @@
           </a:bodyPr>
           <a:lstStyle/>
           <a:p>
+            <a:pPr algn="l">
+              <a:defRPr sz="800" b="1">
+                <a:solidFill>
+                  <a:srgbClr val="606070"/>
+                </a:solidFill>
+                <a:latin typeface="Segoe UI"/>
+              </a:defRPr>
+            </a:pPr>
+            <a:r>
+              <a:t>STARGATE  /  MEETING INTELLIGENCE</a:t>
+            </a:r>
+          </a:p>
+        </p:txBody>
+      </p:sp>
+      <p:sp>
+        <p:nvSpPr>
+          <p:cNvPr id="6" name="MA_PAGE_4"/>
+          <p:cNvSpPr txBox="1"/>
+          <p:nvPr/>
+        </p:nvSpPr>
+        <p:spPr>
+          <a:xfrm>
+            <a:off x="11018520" y="6446520"/>
+            <a:ext cx="548640" cy="182880"/>
+          </a:xfrm>
+          <a:prstGeom prst="rect">
+            <a:avLst/>
+          </a:prstGeom>
+          <a:noFill/>
+        </p:spPr>
+        <p:txBody>
+          <a:bodyPr wrap="square" lIns="0" rIns="0" tIns="0" bIns="0" anchor="t">
+            <a:spAutoFit/>
+          </a:bodyPr>
+          <a:lstStyle/>
+          <a:p>
             <a:pPr algn="r">
               <a:defRPr sz="900" b="0">
                 <a:solidFill>
-                  <a:srgbClr val="68645F"/>
-                </a:solidFill>
-                <a:latin typeface="Aptos"/>
+                  <a:srgbClr val="606070"/>
+                </a:solidFill>
+                <a:latin typeface="Segoe UI"/>
               </a:defRPr>
             </a:pPr>
             <a:r>
@@ -4927,7 +5845,7 @@
       </p:sp>
       <p:sp>
         <p:nvSpPr>
-          <p:cNvPr id="5" name="Rounded Rectangle 4"/>
+          <p:cNvPr id="7" name="Rounded Rectangle 6"/>
           <p:cNvSpPr/>
           <p:nvPr/>
         </p:nvSpPr>
@@ -4944,7 +5862,7 @@
           </a:solidFill>
           <a:ln>
             <a:solidFill>
-              <a:srgbClr val="D9D7D2"/>
+              <a:srgbClr val="D9DCE8"/>
             </a:solidFill>
           </a:ln>
         </p:spPr>
@@ -4972,7 +5890,7 @@
       </p:sp>
       <p:sp>
         <p:nvSpPr>
-          <p:cNvPr id="6" name="Rectangle 5"/>
+          <p:cNvPr id="8" name="Rectangle 7"/>
           <p:cNvSpPr/>
           <p:nvPr/>
         </p:nvSpPr>
@@ -4985,11 +5903,11 @@
             <a:avLst/>
           </a:prstGeom>
           <a:solidFill>
-            <a:srgbClr val="B11F4B"/>
+            <a:srgbClr val="0078D4"/>
           </a:solidFill>
           <a:ln>
             <a:solidFill>
-              <a:srgbClr val="B11F4B"/>
+              <a:srgbClr val="0078D4"/>
             </a:solidFill>
           </a:ln>
         </p:spPr>
@@ -5017,7 +5935,7 @@
       </p:sp>
       <p:sp>
         <p:nvSpPr>
-          <p:cNvPr id="7" name="MA_DECISIONS_LABEL"/>
+          <p:cNvPr id="9" name="MA_DECISIONS_LABEL"/>
           <p:cNvSpPr txBox="1"/>
           <p:nvPr/>
         </p:nvSpPr>
@@ -5042,7 +5960,7 @@
                 <a:solidFill>
                   <a:srgbClr val="FFFFFF"/>
                 </a:solidFill>
-                <a:latin typeface="Aptos"/>
+                <a:latin typeface="Segoe UI"/>
               </a:defRPr>
             </a:pPr>
             <a:r>
@@ -5053,7 +5971,7 @@
       </p:sp>
       <p:sp>
         <p:nvSpPr>
-          <p:cNvPr id="8" name="MA_DECISIONS"/>
+          <p:cNvPr id="10" name="MA_DECISIONS"/>
           <p:cNvSpPr txBox="1"/>
           <p:nvPr/>
         </p:nvSpPr>
@@ -5076,9 +5994,9 @@
             <a:pPr algn="l">
               <a:defRPr sz="1700" b="0">
                 <a:solidFill>
-                  <a:srgbClr val="242424"/>
-                </a:solidFill>
-                <a:latin typeface="Aptos"/>
+                  <a:srgbClr val="1A1A3E"/>
+                </a:solidFill>
+                <a:latin typeface="Segoe UI"/>
               </a:defRPr>
             </a:pPr>
             <a:r>
@@ -5089,7 +6007,7 @@
       </p:sp>
       <p:sp>
         <p:nvSpPr>
-          <p:cNvPr id="9" name="Rounded Rectangle 8"/>
+          <p:cNvPr id="11" name="Rounded Rectangle 10"/>
           <p:cNvSpPr/>
           <p:nvPr/>
         </p:nvSpPr>
@@ -5106,7 +6024,7 @@
           </a:solidFill>
           <a:ln>
             <a:solidFill>
-              <a:srgbClr val="D9D7D2"/>
+              <a:srgbClr val="D9DCE8"/>
             </a:solidFill>
           </a:ln>
         </p:spPr>
@@ -5134,7 +6052,7 @@
       </p:sp>
       <p:sp>
         <p:nvSpPr>
-          <p:cNvPr id="10" name="Rectangle 9"/>
+          <p:cNvPr id="12" name="Rectangle 11"/>
           <p:cNvSpPr/>
           <p:nvPr/>
         </p:nvSpPr>
@@ -5147,11 +6065,11 @@
             <a:avLst/>
           </a:prstGeom>
           <a:solidFill>
-            <a:srgbClr val="007C83"/>
+            <a:srgbClr val="00B04F"/>
           </a:solidFill>
           <a:ln>
             <a:solidFill>
-              <a:srgbClr val="007C83"/>
+              <a:srgbClr val="00B04F"/>
             </a:solidFill>
           </a:ln>
         </p:spPr>
@@ -5179,7 +6097,7 @@
       </p:sp>
       <p:sp>
         <p:nvSpPr>
-          <p:cNvPr id="11" name="MA_ACTIONS_LABEL"/>
+          <p:cNvPr id="13" name="MA_ACTIONS_LABEL"/>
           <p:cNvSpPr txBox="1"/>
           <p:nvPr/>
         </p:nvSpPr>
@@ -5204,7 +6122,7 @@
                 <a:solidFill>
                   <a:srgbClr val="FFFFFF"/>
                 </a:solidFill>
-                <a:latin typeface="Aptos"/>
+                <a:latin typeface="Segoe UI"/>
               </a:defRPr>
             </a:pPr>
             <a:r>
@@ -5215,7 +6133,7 @@
       </p:sp>
       <p:sp>
         <p:nvSpPr>
-          <p:cNvPr id="12" name="MA_ACTIONS"/>
+          <p:cNvPr id="14" name="MA_ACTIONS"/>
           <p:cNvSpPr txBox="1"/>
           <p:nvPr/>
         </p:nvSpPr>
@@ -5238,9 +6156,9 @@
             <a:pPr algn="l">
               <a:defRPr sz="1600" b="0">
                 <a:solidFill>
-                  <a:srgbClr val="242424"/>
-                </a:solidFill>
-                <a:latin typeface="Aptos"/>
+                  <a:srgbClr val="1A1A3E"/>
+                </a:solidFill>
+                <a:latin typeface="Segoe UI"/>
               </a:defRPr>
             </a:pPr>
             <a:r>
@@ -5263,7 +6181,7 @@
     <p:bg>
       <p:bgPr>
         <a:solidFill>
-          <a:srgbClr val="242424"/>
+          <a:srgbClr val="1A1A3E"/>
         </a:solidFill>
         <a:effectLst/>
       </p:bgPr>
@@ -5277,13 +6195,58 @@
       <p:grpSpPr/>
       <p:sp>
         <p:nvSpPr>
-          <p:cNvPr id="2" name="MA_SECTION_5"/>
+          <p:cNvPr id="2" name="Rectangle 1"/>
+          <p:cNvSpPr/>
+          <p:nvPr/>
+        </p:nvSpPr>
+        <p:spPr>
+          <a:xfrm>
+            <a:off x="0" y="0"/>
+            <a:ext cx="12191695" cy="64008"/>
+          </a:xfrm>
+          <a:prstGeom prst="rect">
+            <a:avLst/>
+          </a:prstGeom>
+          <a:solidFill>
+            <a:srgbClr val="0078D4"/>
+          </a:solidFill>
+          <a:ln>
+            <a:solidFill>
+              <a:srgbClr val="0078D4"/>
+            </a:solidFill>
+          </a:ln>
+        </p:spPr>
+        <p:style>
+          <a:lnRef idx="1">
+            <a:schemeClr val="accent1"/>
+          </a:lnRef>
+          <a:fillRef idx="3">
+            <a:schemeClr val="accent1"/>
+          </a:fillRef>
+          <a:effectRef idx="2">
+            <a:schemeClr val="accent1"/>
+          </a:effectRef>
+          <a:fontRef idx="minor">
+            <a:schemeClr val="lt1"/>
+          </a:fontRef>
+        </p:style>
+        <p:txBody>
+          <a:bodyPr rtlCol="0" anchor="ctr"/>
+          <a:lstStyle/>
+          <a:p>
+            <a:pPr algn="ctr"/>
+          </a:p>
+        </p:txBody>
+      </p:sp>
+      <p:sp>
+        <p:nvSpPr>
+          <p:cNvPr id="3" name="MA_SECTION_5"/>
           <p:cNvSpPr txBox="1"/>
           <p:nvPr/>
         </p:nvSpPr>
         <p:spPr>
           <a:xfrm>
-            <a:off x="594360" y="347472"/>
+            <a:off x="530352" y="265176"/>
             <a:ext cx="2560320" cy="274320"/>
           </a:xfrm>
           <a:prstGeom prst="rect">
@@ -5298,11 +6261,11 @@
           <a:lstStyle/>
           <a:p>
             <a:pPr algn="l">
-              <a:defRPr sz="1000" b="1">
-                <a:solidFill>
-                  <a:srgbClr val="B11F4B"/>
-                </a:solidFill>
-                <a:latin typeface="Aptos"/>
+              <a:defRPr sz="900" b="1">
+                <a:solidFill>
+                  <a:srgbClr val="0078D4"/>
+                </a:solidFill>
+                <a:latin typeface="Segoe UI"/>
               </a:defRPr>
             </a:pPr>
             <a:r>
@@ -5313,13 +6276,13 @@
       </p:sp>
       <p:sp>
         <p:nvSpPr>
-          <p:cNvPr id="3" name="MA_SLIDE_TITLE_5"/>
+          <p:cNvPr id="4" name="MA_SLIDE_TITLE_5"/>
           <p:cNvSpPr txBox="1"/>
           <p:nvPr/>
         </p:nvSpPr>
         <p:spPr>
           <a:xfrm>
-            <a:off x="594360" y="713232"/>
+            <a:off x="530352" y="612648"/>
             <a:ext cx="10789920" cy="594360"/>
           </a:xfrm>
           <a:prstGeom prst="rect">
@@ -5334,11 +6297,11 @@
           <a:lstStyle/>
           <a:p>
             <a:pPr algn="l">
-              <a:defRPr sz="3000" b="1">
+              <a:defRPr sz="2800" b="1">
                 <a:solidFill>
                   <a:srgbClr val="FFFFFF"/>
                 </a:solidFill>
-                <a:latin typeface="Aptos"/>
+                <a:latin typeface="Segoe UI"/>
               </a:defRPr>
             </a:pPr>
             <a:r>
@@ -5349,14 +6312,14 @@
       </p:sp>
       <p:sp>
         <p:nvSpPr>
-          <p:cNvPr id="4" name="MA_PAGE_5"/>
+          <p:cNvPr id="5" name="MA_FOOTER_5"/>
           <p:cNvSpPr txBox="1"/>
           <p:nvPr/>
         </p:nvSpPr>
         <p:spPr>
           <a:xfrm>
-            <a:off x="11018520" y="6446520"/>
-            <a:ext cx="548640" cy="182880"/>
+            <a:off x="530352" y="6446520"/>
+            <a:ext cx="4297680" cy="182880"/>
           </a:xfrm>
           <a:prstGeom prst="rect">
             <a:avLst/>
@@ -5369,12 +6332,48 @@
           </a:bodyPr>
           <a:lstStyle/>
           <a:p>
+            <a:pPr algn="l">
+              <a:defRPr sz="800" b="1">
+                <a:solidFill>
+                  <a:srgbClr val="FFFFFF"/>
+                </a:solidFill>
+                <a:latin typeface="Segoe UI"/>
+              </a:defRPr>
+            </a:pPr>
+            <a:r>
+              <a:t>STARGATE  /  MEETING INTELLIGENCE</a:t>
+            </a:r>
+          </a:p>
+        </p:txBody>
+      </p:sp>
+      <p:sp>
+        <p:nvSpPr>
+          <p:cNvPr id="6" name="MA_PAGE_5"/>
+          <p:cNvSpPr txBox="1"/>
+          <p:nvPr/>
+        </p:nvSpPr>
+        <p:spPr>
+          <a:xfrm>
+            <a:off x="11018520" y="6446520"/>
+            <a:ext cx="548640" cy="182880"/>
+          </a:xfrm>
+          <a:prstGeom prst="rect">
+            <a:avLst/>
+          </a:prstGeom>
+          <a:noFill/>
+        </p:spPr>
+        <p:txBody>
+          <a:bodyPr wrap="square" lIns="0" rIns="0" tIns="0" bIns="0" anchor="t">
+            <a:spAutoFit/>
+          </a:bodyPr>
+          <a:lstStyle/>
+          <a:p>
             <a:pPr algn="r">
               <a:defRPr sz="900" b="0">
                 <a:solidFill>
-                  <a:srgbClr val="68645F"/>
-                </a:solidFill>
-                <a:latin typeface="Aptos"/>
+                  <a:srgbClr val="606070"/>
+                </a:solidFill>
+                <a:latin typeface="Segoe UI"/>
               </a:defRPr>
             </a:pPr>
             <a:r>
@@ -5385,7 +6384,7 @@
       </p:sp>
       <p:sp>
         <p:nvSpPr>
-          <p:cNvPr id="5" name="MA_MIND_MAP_FRAME"/>
+          <p:cNvPr id="7" name="MA_MIND_MAP_FRAME"/>
           <p:cNvSpPr/>
           <p:nvPr/>
         </p:nvSpPr>
@@ -5430,7 +6429,7 @@
       </p:sp>
       <p:sp>
         <p:nvSpPr>
-          <p:cNvPr id="6" name="MA_MIND_MAP_NOTE"/>
+          <p:cNvPr id="8" name="MA_MIND_MAP_NOTE"/>
           <p:cNvSpPr txBox="1"/>
           <p:nvPr/>
         </p:nvSpPr>
@@ -5455,7 +6454,7 @@
                 <a:solidFill>
                   <a:srgbClr val="FFFFFF"/>
                 </a:solidFill>
-                <a:latin typeface="Aptos"/>
+                <a:latin typeface="Segoe UI"/>
               </a:defRPr>
             </a:pPr>
             <a:r>
@@ -5478,7 +6477,7 @@
     <p:bg>
       <p:bgPr>
         <a:solidFill>
-          <a:srgbClr val="F7F4EF"/>
+          <a:srgbClr val="FFFFFF"/>
         </a:solidFill>
         <a:effectLst/>
       </p:bgPr>
@@ -5492,13 +6491,58 @@
       <p:grpSpPr/>
       <p:sp>
         <p:nvSpPr>
-          <p:cNvPr id="2" name="MA_SECTION_6"/>
+          <p:cNvPr id="2" name="Rectangle 1"/>
+          <p:cNvSpPr/>
+          <p:nvPr/>
+        </p:nvSpPr>
+        <p:spPr>
+          <a:xfrm>
+            <a:off x="0" y="0"/>
+            <a:ext cx="12191695" cy="64008"/>
+          </a:xfrm>
+          <a:prstGeom prst="rect">
+            <a:avLst/>
+          </a:prstGeom>
+          <a:solidFill>
+            <a:srgbClr val="0078D4"/>
+          </a:solidFill>
+          <a:ln>
+            <a:solidFill>
+              <a:srgbClr val="0078D4"/>
+            </a:solidFill>
+          </a:ln>
+        </p:spPr>
+        <p:style>
+          <a:lnRef idx="1">
+            <a:schemeClr val="accent1"/>
+          </a:lnRef>
+          <a:fillRef idx="3">
+            <a:schemeClr val="accent1"/>
+          </a:fillRef>
+          <a:effectRef idx="2">
+            <a:schemeClr val="accent1"/>
+          </a:effectRef>
+          <a:fontRef idx="minor">
+            <a:schemeClr val="lt1"/>
+          </a:fontRef>
+        </p:style>
+        <p:txBody>
+          <a:bodyPr rtlCol="0" anchor="ctr"/>
+          <a:lstStyle/>
+          <a:p>
+            <a:pPr algn="ctr"/>
+          </a:p>
+        </p:txBody>
+      </p:sp>
+      <p:sp>
+        <p:nvSpPr>
+          <p:cNvPr id="3" name="MA_SECTION_6"/>
           <p:cNvSpPr txBox="1"/>
           <p:nvPr/>
         </p:nvSpPr>
         <p:spPr>
           <a:xfrm>
-            <a:off x="594360" y="347472"/>
+            <a:off x="530352" y="265176"/>
             <a:ext cx="2560320" cy="274320"/>
           </a:xfrm>
           <a:prstGeom prst="rect">
@@ -5513,11 +6557,11 @@
           <a:lstStyle/>
           <a:p>
             <a:pPr algn="l">
-              <a:defRPr sz="1000" b="1">
-                <a:solidFill>
-                  <a:srgbClr val="B11F4B"/>
-                </a:solidFill>
-                <a:latin typeface="Aptos"/>
+              <a:defRPr sz="900" b="1">
+                <a:solidFill>
+                  <a:srgbClr val="0078D4"/>
+                </a:solidFill>
+                <a:latin typeface="Segoe UI"/>
               </a:defRPr>
             </a:pPr>
             <a:r>
@@ -5528,13 +6572,13 @@
       </p:sp>
       <p:sp>
         <p:nvSpPr>
-          <p:cNvPr id="3" name="MA_SLIDE_TITLE_6"/>
+          <p:cNvPr id="4" name="MA_SLIDE_TITLE_6"/>
           <p:cNvSpPr txBox="1"/>
           <p:nvPr/>
         </p:nvSpPr>
         <p:spPr>
           <a:xfrm>
-            <a:off x="594360" y="713232"/>
+            <a:off x="530352" y="612648"/>
             <a:ext cx="10789920" cy="594360"/>
           </a:xfrm>
           <a:prstGeom prst="rect">
@@ -5549,11 +6593,11 @@
           <a:lstStyle/>
           <a:p>
             <a:pPr algn="l">
-              <a:defRPr sz="3000" b="1">
-                <a:solidFill>
-                  <a:srgbClr val="242424"/>
-                </a:solidFill>
-                <a:latin typeface="Aptos"/>
+              <a:defRPr sz="2800" b="1">
+                <a:solidFill>
+                  <a:srgbClr val="1A1A3E"/>
+                </a:solidFill>
+                <a:latin typeface="Segoe UI"/>
               </a:defRPr>
             </a:pPr>
             <a:r>
@@ -5564,14 +6608,14 @@
       </p:sp>
       <p:sp>
         <p:nvSpPr>
-          <p:cNvPr id="4" name="MA_PAGE_6"/>
+          <p:cNvPr id="5" name="MA_FOOTER_6"/>
           <p:cNvSpPr txBox="1"/>
           <p:nvPr/>
         </p:nvSpPr>
         <p:spPr>
           <a:xfrm>
-            <a:off x="11018520" y="6446520"/>
-            <a:ext cx="548640" cy="182880"/>
+            <a:off x="530352" y="6446520"/>
+            <a:ext cx="4297680" cy="182880"/>
           </a:xfrm>
           <a:prstGeom prst="rect">
             <a:avLst/>
@@ -5584,12 +6628,48 @@
           </a:bodyPr>
           <a:lstStyle/>
           <a:p>
+            <a:pPr algn="l">
+              <a:defRPr sz="800" b="1">
+                <a:solidFill>
+                  <a:srgbClr val="606070"/>
+                </a:solidFill>
+                <a:latin typeface="Segoe UI"/>
+              </a:defRPr>
+            </a:pPr>
+            <a:r>
+              <a:t>STARGATE  /  MEETING INTELLIGENCE</a:t>
+            </a:r>
+          </a:p>
+        </p:txBody>
+      </p:sp>
+      <p:sp>
+        <p:nvSpPr>
+          <p:cNvPr id="6" name="MA_PAGE_6"/>
+          <p:cNvSpPr txBox="1"/>
+          <p:nvPr/>
+        </p:nvSpPr>
+        <p:spPr>
+          <a:xfrm>
+            <a:off x="11018520" y="6446520"/>
+            <a:ext cx="548640" cy="182880"/>
+          </a:xfrm>
+          <a:prstGeom prst="rect">
+            <a:avLst/>
+          </a:prstGeom>
+          <a:noFill/>
+        </p:spPr>
+        <p:txBody>
+          <a:bodyPr wrap="square" lIns="0" rIns="0" tIns="0" bIns="0" anchor="t">
+            <a:spAutoFit/>
+          </a:bodyPr>
+          <a:lstStyle/>
+          <a:p>
             <a:pPr algn="r">
               <a:defRPr sz="900" b="0">
                 <a:solidFill>
-                  <a:srgbClr val="68645F"/>
-                </a:solidFill>
-                <a:latin typeface="Aptos"/>
+                  <a:srgbClr val="606070"/>
+                </a:solidFill>
+                <a:latin typeface="Segoe UI"/>
               </a:defRPr>
             </a:pPr>
             <a:r>
@@ -5600,7 +6680,7 @@
       </p:sp>
       <p:sp>
         <p:nvSpPr>
-          <p:cNvPr id="5" name="Rounded Rectangle 4"/>
+          <p:cNvPr id="7" name="Rounded Rectangle 6"/>
           <p:cNvSpPr/>
           <p:nvPr/>
         </p:nvSpPr>
@@ -5617,7 +6697,7 @@
           </a:solidFill>
           <a:ln>
             <a:solidFill>
-              <a:srgbClr val="D9D7D2"/>
+              <a:srgbClr val="D9DCE8"/>
             </a:solidFill>
           </a:ln>
         </p:spPr>
@@ -5645,7 +6725,7 @@
       </p:sp>
       <p:sp>
         <p:nvSpPr>
-          <p:cNvPr id="6" name="MA_QUESTIONS"/>
+          <p:cNvPr id="8" name="MA_QUESTIONS"/>
           <p:cNvSpPr txBox="1"/>
           <p:nvPr/>
         </p:nvSpPr>
@@ -5668,9 +6748,9 @@
             <a:pPr algn="l">
               <a:defRPr sz="1800" b="0">
                 <a:solidFill>
-                  <a:srgbClr val="242424"/>
-                </a:solidFill>
-                <a:latin typeface="Aptos"/>
+                  <a:srgbClr val="1A1A3E"/>
+                </a:solidFill>
+                <a:latin typeface="Segoe UI"/>
               </a:defRPr>
             </a:pPr>
             <a:r>
@@ -5681,7 +6761,7 @@
       </p:sp>
       <p:sp>
         <p:nvSpPr>
-          <p:cNvPr id="7" name="Rectangle 6"/>
+          <p:cNvPr id="9" name="Rectangle 8"/>
           <p:cNvSpPr/>
           <p:nvPr/>
         </p:nvSpPr>
@@ -5694,11 +6774,11 @@
             <a:avLst/>
           </a:prstGeom>
           <a:solidFill>
-            <a:srgbClr val="007C83"/>
+            <a:srgbClr val="00B04F"/>
           </a:solidFill>
           <a:ln>
             <a:solidFill>
-              <a:srgbClr val="007C83"/>
+              <a:srgbClr val="00B04F"/>
             </a:solidFill>
           </a:ln>
         </p:spPr>
@@ -5726,7 +6806,7 @@
       </p:sp>
       <p:sp>
         <p:nvSpPr>
-          <p:cNvPr id="8" name="MA_NEXT_LABEL"/>
+          <p:cNvPr id="10" name="MA_NEXT_LABEL"/>
           <p:cNvSpPr txBox="1"/>
           <p:nvPr/>
         </p:nvSpPr>
@@ -5751,7 +6831,7 @@
                 <a:solidFill>
                   <a:srgbClr val="FFFFFF"/>
                 </a:solidFill>
-                <a:latin typeface="Aptos"/>
+                <a:latin typeface="Segoe UI"/>
               </a:defRPr>
             </a:pPr>
             <a:r>
@@ -5762,7 +6842,7 @@
       </p:sp>
       <p:sp>
         <p:nvSpPr>
-          <p:cNvPr id="9" name="MA_NEXT_STEP"/>
+          <p:cNvPr id="11" name="MA_NEXT_STEP"/>
           <p:cNvSpPr txBox="1"/>
           <p:nvPr/>
         </p:nvSpPr>
@@ -5787,7 +6867,7 @@
                 <a:solidFill>
                   <a:srgbClr val="FFFFFF"/>
                 </a:solidFill>
-                <a:latin typeface="Aptos"/>
+                <a:latin typeface="Segoe UI"/>
               </a:defRPr>
             </a:pPr>
             <a:r>
@@ -5798,7 +6878,7 @@
       </p:sp>
       <p:sp>
         <p:nvSpPr>
-          <p:cNvPr id="10" name="MA_CLOSE"/>
+          <p:cNvPr id="12" name="MA_CLOSE"/>
           <p:cNvSpPr txBox="1"/>
           <p:nvPr/>
         </p:nvSpPr>
@@ -5823,7 +6903,7 @@
                 <a:solidFill>
                   <a:srgbClr val="FFFFFF"/>
                 </a:solidFill>
-                <a:latin typeface="Aptos"/>
+                <a:latin typeface="Segoe UI"/>
               </a:defRPr>
             </a:pPr>
             <a:r>

</xml_diff>